<commit_message>
Sim-Review M06: 8 VPs + Artefakte neu + sim_review true
Co-Authored-By: Claude Fable 5 <noreply@anthropic.com>
</commit_message>
<xml_diff>
--- a/protected-downloads/praesentation/M06.pptx
+++ b/protected-downloads/praesentation/M06.pptx
@@ -8264,7 +8264,7 @@
                 </a:solidFill>
                 <a:latin typeface="Consolas"/>
               </a:rPr>
-              <a:t>00:45–01:15 </a:t>
+              <a:t>00:45–01:20 </a:t>
             </a:r>
             <a:r>
               <a:rPr sz="1500" b="1">
@@ -8301,7 +8301,7 @@
                 </a:solidFill>
                 <a:latin typeface="Consolas"/>
               </a:rPr>
-              <a:t>01:15–01:30 </a:t>
+              <a:t>01:20–01:35 </a:t>
             </a:r>
             <a:r>
               <a:rPr sz="1500" b="1">
@@ -8338,7 +8338,7 @@
                 </a:solidFill>
                 <a:latin typeface="Consolas"/>
               </a:rPr>
-              <a:t>01:30–01:40 </a:t>
+              <a:t>01:35–01:45 </a:t>
             </a:r>
             <a:r>
               <a:rPr sz="1500" b="1">

</xml_diff>

<commit_message>
M-Track Batch 2: M06 Deck (Web/Workbook)
Co-Authored-By: Claude Fable 5 <noreply@anthropic.com>
</commit_message>
<xml_diff>
--- a/protected-downloads/praesentation/M06.pptx
+++ b/protected-downloads/praesentation/M06.pptx
@@ -19,6 +19,8 @@
     <p:sldId id="267" r:id="rId19"/>
     <p:sldId id="268" r:id="rId20"/>
     <p:sldId id="269" r:id="rId21"/>
+    <p:sldId id="270" r:id="rId22"/>
+    <p:sldId id="271" r:id="rId23"/>
   </p:sldIdLst>
   <p:sldSz cx="12188952" cy="6858000" type="screen4x3"/>
   <p:notesSz cx="6858000" cy="9144000"/>
@@ -585,7 +587,7 @@
           <a:lstStyle/>
           <a:p>
             <a:r>
-              <a:t>Siehe Trainerhandbuch (Sektion 3) für Moderationshinweise, Timing und erwartete Teilnehmerreaktionen.</a:t>
+              <a:t>Einstieg: das Hausbank-Prinzip beruht auf Vertrauen – der Berater kennt den Menschen hinter der Bilanz.</a:t>
             </a:r>
           </a:p>
         </p:txBody>
@@ -655,7 +657,7 @@
           <a:lstStyle/>
           <a:p>
             <a:r>
-              <a:t>Siehe Trainerhandbuch (Sektion 3) für Moderationshinweise, Timing und erwartete Teilnehmerreaktionen.</a:t>
+              <a:t>Fünf KMU-Grundkategorien und die volkswirtschaftliche Bedeutung als Rückgrat der Region.</a:t>
             </a:r>
           </a:p>
         </p:txBody>
@@ -725,7 +727,7 @@
           <a:lstStyle/>
           <a:p>
             <a:r>
-              <a:t>Siehe Trainerhandbuch (Sektion 3) für Moderationshinweise, Timing und erwartete Teilnehmerreaktionen.</a:t>
+              <a:t>Jedes Risikofeld ist zugleich eine Beratungsopportunität: aus der Risikoanalyse folgt der Verbundimpuls (z. B. R+V Schlüsselpersonenversicherung) – empfohlen, nicht verkauft.</a:t>
             </a:r>
           </a:p>
         </p:txBody>
@@ -795,102 +797,7 @@
           <a:lstStyle/>
           <a:p>
             <a:r>
-              <a:t>Musterlösung (Trainer-Version – nicht für Teilnehmer sichtbar)</a:t>
-            </a:r>
-          </a:p>
-          <a:p>
-            <a:r>
-              <a:t>Zu Aufgabe 1:</a:t>
-            </a:r>
-          </a:p>
-          <a:p>
-            <a:r>
-              <a:t>IfM Bonn: ✓ KMU – 8 Beschäftigte &lt; 500, 1,8 Mio. EUR &lt; 50 Mio. EUR; inhabergeführt (Sabine Bergmann = Eigentümerin und Geschäftsführerin)</a:t>
-            </a:r>
-          </a:p>
-          <a:p>
-            <a:r>
-              <a:t>EU: Kleinunternehmen – &lt; 50 Beschäftigte, &lt; 10 Mio. EUR Umsatz; damit förderberechtigt für KfW-Kleinunternehmerkredite und EU-Strukturfonds</a:t>
-            </a:r>
-          </a:p>
-          <a:p>
-            <a:r>
-              <a:t>Zu Aufgabe 2:</a:t>
-            </a:r>
-          </a:p>
-          <a:p>
-            <a:r>
-              <a:t>Branchenprofil A (Handwerk), speziell Tischlerhandwerk / Holzgewerbe (WZ 16.29)</a:t>
-            </a:r>
-          </a:p>
-          <a:p>
-            <a:r>
-              <a:t>Risikofelder: (1) Inhaberabhängigkeit – Sabine Bergmann ist die einzige Führungskraft, kein Vertretungskonzept erkennbar; (2) Klumpenrisiko – bei 1,8 Mio. EUR Umsatz und 8 Mitarbeitern ist anzunehmen, dass wenige Großkunden dominieren; (3) Working-Capital-/Liquiditätsrisiko – Kontokorrentlinie bereits zu 71 % ausgeschöpft + laufender Investitionskredit; ein weiterer Kredit erhöht den Schuldendienst und engt den Liquiditätspuffer weiter ein; (4) Fachkräfterisiko – 3 von 8 Mitarbeitern sind Azubis, Abgang eines Gesellen = sofortige massive Kapazitätseinbuße; im Holzhandwerk 2025 das drängendste operative Risiko; (Nachfolgehinweis: Zwar 2020 vollzogen, aber Vater könnte noch informal eingebunden sein – dies als Gesprächspunkt vormerken, kein eigenständiges Hauptrisikofeld)</a:t>
-            </a:r>
-          </a:p>
-          <a:p>
-            <a:r>
-              <a:t>Zu Aufgabe 4:</a:t>
-            </a:r>
-          </a:p>
-          <a:p>
-            <a:r>
-              <a:t>Frage 1: Warum ist die KK-Linie so stark ausgeschöpft – strukturell (saisonale Spitze?) oder dauerhaft?</a:t>
-            </a:r>
-          </a:p>
-          <a:p>
-            <a:r>
-              <a:t>Frage 2: Reicht die Linie in ihrer aktuellen Höhe noch, wenn der neue Kredit läuft und die Jahresrate hinzukommt?</a:t>
-            </a:r>
-          </a:p>
-          <a:p>
-            <a:r>
-              <a:t>Frage 3: Müsste vor dem Investitionskredit erst die KK-Linie erhöht oder der KK-Saldo reduziert werden?</a:t>
-            </a:r>
-          </a:p>
-          <a:p>
-            <a:r>
-              <a:t>Reihenfolge: Erst KK-Situation klären (Gespräch über aktuelle Liquiditätslage), dann Tragfähigkeitsrechnung, dann Kreditgespräch. Wer zuerst den Investitionskredit bewilligt, riskiert eine Liquiditätsfalle.</a:t>
-            </a:r>
-          </a:p>
-          <a:p>
-            <a:r>
-              <a:t>Zu Aufgabe 3:</a:t>
-            </a:r>
-          </a:p>
-          <a:p>
-            <a:r>
-              <a:t>Beispiel-Formulierungen:</a:t>
-            </a:r>
-          </a:p>
-          <a:p>
-            <a:r>
-              <a:t>1. "Frau Bergmann, Sie bauen Möbel und Innenausbauten – haben Sie eher Privat- oder Gewerbekunden, und was macht bei Ihnen das bessere Geschäft?"</a:t>
-            </a:r>
-          </a:p>
-          <a:p>
-            <a:r>
-              <a:t>2. "Ihre größten Auftraggeber – gibt es da 2–3 Kunden, auf die ein großer Teil des Umsatzes entfällt?"</a:t>
-            </a:r>
-          </a:p>
-          <a:p>
-            <a:r>
-              <a:t>3. "Was ist gerade Ihr größtes Thema für die nächsten 12 Monate – ist es die Maschine, oder gibt es da noch mehr?"</a:t>
-            </a:r>
-          </a:p>
-          <a:p>
-            <a:r>
-              <a:t>4. "Wie haben Sie bisher größere Investitionen finanziert – eher aus eigener Kraft oder mit Bankunterstützung?"</a:t>
-            </a:r>
-          </a:p>
-          <a:p>
-            <a:r>
-              <a:t>5. "Frau Bergmann, ich frage Sie etwas, das viele selten durchdenken: Was würde passieren, wenn Sie 6 Monate krankheitsbedingt ausfallen würden – wer würde den Betrieb führen?"</a:t>
-            </a:r>
-          </a:p>
-          <a:p>
-            <a:r>
-              <a:t>Erwartete Antwort auf Frage 5: "Das wäre schwierig. Ich bin für alles zuständig – Kundenakquise, Auftragsplanung, die Maschinen kenne ich alle. Mein Mann könnte vielleicht einspringen, aber der hat einen anderen Job." → Beratungsopportunität: Schlüsselpersonenversicherung (R+V), ggf. Geschäftsführer-Krankengeldabsicherung.</a:t>
+              <a:t>Das 5-Fragen-Schema als niederschwelliger Einstieg – anwendbar auch ohne tiefe Branchenkenntnis.</a:t>
             </a:r>
           </a:p>
         </p:txBody>
@@ -960,7 +867,222 @@
           <a:lstStyle/>
           <a:p>
             <a:r>
-              <a:t>Siehe Trainerhandbuch (Sektion 3) für Moderationshinweise, Timing und erwartete Teilnehmerreaktionen.</a:t>
+              <a:t>Die Zahlen sind branchentypisch unauffällig – das Risiko liegt in der Struktur (8 MA, inhabergeführt): Schlüsselperson und Nachfolge.</a:t>
+            </a:r>
+          </a:p>
+        </p:txBody>
+      </p:sp>
+      <p:sp>
+        <p:nvSpPr>
+          <p:cNvPr id="4" name="Slide Number Placeholder 3"/>
+          <p:cNvSpPr>
+            <a:spLocks noGrp="1"/>
+          </p:cNvSpPr>
+          <p:nvPr>
+            <p:ph type="sldNum" idx="5" sz="quarter"/>
+          </p:nvPr>
+        </p:nvSpPr>
+        <p:spPr/>
+      </p:sp>
+    </p:spTree>
+  </p:cSld>
+  <p:clrMapOvr>
+    <a:masterClrMapping/>
+  </p:clrMapOvr>
+</p:notes>
+</file>
+
+<file path=ppt/notesSlides/notesSlide7.xml><?xml version="1.0" encoding="utf-8"?>
+<p:notes xmlns:a="http://schemas.openxmlformats.org/drawingml/2006/main" xmlns:p="http://schemas.openxmlformats.org/presentationml/2006/main" xmlns:r="http://schemas.openxmlformats.org/officeDocument/2006/relationships">
+  <p:cSld>
+    <p:spTree>
+      <p:nvGrpSpPr>
+        <p:cNvPr id="1" name=""/>
+        <p:cNvGrpSpPr/>
+        <p:nvPr/>
+      </p:nvGrpSpPr>
+      <p:grpSpPr>
+        <a:xfrm>
+          <a:off x="0" y="0"/>
+          <a:ext cx="0" cy="0"/>
+          <a:chOff x="0" y="0"/>
+          <a:chExt cx="0" cy="0"/>
+        </a:xfrm>
+      </p:grpSpPr>
+      <p:sp>
+        <p:nvSpPr>
+          <p:cNvPr id="2" name="Slide Image Placeholder 1"/>
+          <p:cNvSpPr>
+            <a:spLocks noGrp="1"/>
+          </p:cNvSpPr>
+          <p:nvPr>
+            <p:ph type="sldImg" idx="2"/>
+          </p:nvPr>
+        </p:nvSpPr>
+        <p:spPr/>
+      </p:sp>
+      <p:sp>
+        <p:nvSpPr>
+          <p:cNvPr id="3" name="Notes Placeholder 2"/>
+          <p:cNvSpPr>
+            <a:spLocks noGrp="1"/>
+          </p:cNvSpPr>
+          <p:nvPr>
+            <p:ph type="body" idx="3" sz="quarter"/>
+          </p:nvPr>
+        </p:nvSpPr>
+        <p:spPr/>
+        <p:txBody>
+          <a:bodyPr/>
+          <a:lstStyle/>
+          <a:p>
+            <a:r>
+              <a:t>AB-1 Musterlösung (Trainer-Version)</a:t>
+            </a:r>
+          </a:p>
+          <a:p>
+            <a:r>
+              <a:t>Bergmann: solide Kennzahlen, aber klassisches Schlüsselpersonen- und Nachfolgerisiko bei 8 MA. Beratungsopportunität: Schlüsselpersonen-/BU-Absicherung (R+V) aus der Risikoanalyse heraus.</a:t>
+            </a:r>
+          </a:p>
+        </p:txBody>
+      </p:sp>
+      <p:sp>
+        <p:nvSpPr>
+          <p:cNvPr id="4" name="Slide Number Placeholder 3"/>
+          <p:cNvSpPr>
+            <a:spLocks noGrp="1"/>
+          </p:cNvSpPr>
+          <p:nvPr>
+            <p:ph type="sldNum" idx="5" sz="quarter"/>
+          </p:nvPr>
+        </p:nvSpPr>
+        <p:spPr/>
+      </p:sp>
+    </p:spTree>
+  </p:cSld>
+  <p:clrMapOvr>
+    <a:masterClrMapping/>
+  </p:clrMapOvr>
+</p:notes>
+</file>
+
+<file path=ppt/notesSlides/notesSlide8.xml><?xml version="1.0" encoding="utf-8"?>
+<p:notes xmlns:a="http://schemas.openxmlformats.org/drawingml/2006/main" xmlns:p="http://schemas.openxmlformats.org/presentationml/2006/main" xmlns:r="http://schemas.openxmlformats.org/officeDocument/2006/relationships">
+  <p:cSld>
+    <p:spTree>
+      <p:nvGrpSpPr>
+        <p:cNvPr id="1" name=""/>
+        <p:cNvGrpSpPr/>
+        <p:nvPr/>
+      </p:nvGrpSpPr>
+      <p:grpSpPr>
+        <a:xfrm>
+          <a:off x="0" y="0"/>
+          <a:ext cx="0" cy="0"/>
+          <a:chOff x="0" y="0"/>
+          <a:chExt cx="0" cy="0"/>
+        </a:xfrm>
+      </p:grpSpPr>
+      <p:sp>
+        <p:nvSpPr>
+          <p:cNvPr id="2" name="Slide Image Placeholder 1"/>
+          <p:cNvSpPr>
+            <a:spLocks noGrp="1"/>
+          </p:cNvSpPr>
+          <p:nvPr>
+            <p:ph type="sldImg" idx="2"/>
+          </p:nvPr>
+        </p:nvSpPr>
+        <p:spPr/>
+      </p:sp>
+      <p:sp>
+        <p:nvSpPr>
+          <p:cNvPr id="3" name="Notes Placeholder 2"/>
+          <p:cNvSpPr>
+            <a:spLocks noGrp="1"/>
+          </p:cNvSpPr>
+          <p:nvPr>
+            <p:ph type="body" idx="3" sz="quarter"/>
+          </p:nvPr>
+        </p:nvSpPr>
+        <p:spPr/>
+        <p:txBody>
+          <a:bodyPr/>
+          <a:lstStyle/>
+          <a:p>
+            <a:r>
+              <a:t>Überleitung zum Profilbogen (AB-2) und Transfer.</a:t>
+            </a:r>
+          </a:p>
+        </p:txBody>
+      </p:sp>
+      <p:sp>
+        <p:nvSpPr>
+          <p:cNvPr id="4" name="Slide Number Placeholder 3"/>
+          <p:cNvSpPr>
+            <a:spLocks noGrp="1"/>
+          </p:cNvSpPr>
+          <p:nvPr>
+            <p:ph type="sldNum" idx="5" sz="quarter"/>
+          </p:nvPr>
+        </p:nvSpPr>
+        <p:spPr/>
+      </p:sp>
+    </p:spTree>
+  </p:cSld>
+  <p:clrMapOvr>
+    <a:masterClrMapping/>
+  </p:clrMapOvr>
+</p:notes>
+</file>
+
+<file path=ppt/notesSlides/notesSlide9.xml><?xml version="1.0" encoding="utf-8"?>
+<p:notes xmlns:a="http://schemas.openxmlformats.org/drawingml/2006/main" xmlns:p="http://schemas.openxmlformats.org/presentationml/2006/main" xmlns:r="http://schemas.openxmlformats.org/officeDocument/2006/relationships">
+  <p:cSld>
+    <p:spTree>
+      <p:nvGrpSpPr>
+        <p:cNvPr id="1" name=""/>
+        <p:cNvGrpSpPr/>
+        <p:nvPr/>
+      </p:nvGrpSpPr>
+      <p:grpSpPr>
+        <a:xfrm>
+          <a:off x="0" y="0"/>
+          <a:ext cx="0" cy="0"/>
+          <a:chOff x="0" y="0"/>
+          <a:chExt cx="0" cy="0"/>
+        </a:xfrm>
+      </p:grpSpPr>
+      <p:sp>
+        <p:nvSpPr>
+          <p:cNvPr id="2" name="Slide Image Placeholder 1"/>
+          <p:cNvSpPr>
+            <a:spLocks noGrp="1"/>
+          </p:cNvSpPr>
+          <p:nvPr>
+            <p:ph type="sldImg" idx="2"/>
+          </p:nvPr>
+        </p:nvSpPr>
+        <p:spPr/>
+      </p:sp>
+      <p:sp>
+        <p:nvSpPr>
+          <p:cNvPr id="3" name="Notes Placeholder 2"/>
+          <p:cNvSpPr>
+            <a:spLocks noGrp="1"/>
+          </p:cNvSpPr>
+          <p:nvPr>
+            <p:ph type="body" idx="3" sz="quarter"/>
+          </p:nvPr>
+        </p:nvSpPr>
+        <p:spPr/>
+        <p:txBody>
+          <a:bodyPr/>
+          <a:lstStyle/>
+          <a:p>
+            <a:r>
+              <a:t>Selbstcheck und Profilbogen als Transferanker.</a:t>
             </a:r>
           </a:p>
         </p:txBody>
@@ -4778,7 +4900,7 @@
                 </a:solidFill>
                 <a:latin typeface="Arial"/>
               </a:rPr>
-              <a:t>Theorie-Input 3: Einstieg in die Branchenanalyse</a:t>
+              <a:t>Zahlen brauchen Kontext</a:t>
             </a:r>
           </a:p>
         </p:txBody>
@@ -4800,27 +4922,27 @@
           <a:noFill/>
         </p:spPr>
         <p:txBody>
-          <a:bodyPr wrap="square">
+          <a:bodyPr wrap="square" anchor="ctr">
             <a:spAutoFit/>
           </a:bodyPr>
           <a:lstStyle/>
           <a:p>
-            <a:pPr>
+            <a:pPr marL="177800" indent="-177800">
               <a:spcBef>
-                <a:spcPts val="1000"/>
+                <a:spcPts val="600"/>
               </a:spcBef>
               <a:spcAft>
                 <a:spcPts val="200"/>
               </a:spcAft>
             </a:pPr>
             <a:r>
-              <a:rPr sz="800" b="1">
-                <a:solidFill>
-                  <a:srgbClr val="78808C"/>
-                </a:solidFill>
-                <a:latin typeface="Consolas"/>
+              <a:rPr sz="1200" i="1">
+                <a:solidFill>
+                  <a:srgbClr val="3D5466"/>
+                </a:solidFill>
+                <a:latin typeface="Arial"/>
               </a:rPr>
-              <a:t>VIER BRANCHENPROFILE FÜR DEN BERATUNGSALLTAG</a:t>
+              <a:t>→  Eine Kennzahl ohne Branchenkontext ist eine Zahl ohne Bedeutung – erst der Vergleich macht sie zur Aussage.</a:t>
             </a:r>
           </a:p>
           <a:p>
@@ -4839,7 +4961,7 @@
                 </a:solidFill>
                 <a:latin typeface="Arial"/>
               </a:rPr>
-              <a:t>▸  Branchenprofil A – Handwerk (z.B. Schreiner, Maler, Sanitär, Bäcker)</a:t>
+              <a:t>▸  Vier Branchenprofile für den Beratungsalltag als Orientierung.</a:t>
             </a:r>
           </a:p>
           <a:p>
@@ -4858,159 +4980,7 @@
                 </a:solidFill>
                 <a:latin typeface="Arial"/>
               </a:rPr>
-              <a:t>▸  Das Handwerk ist der typischste KMU-Sektor im süddeutschen VR-Kundenbestand. Charakteristisch:</a:t>
-            </a:r>
-          </a:p>
-          <a:p>
-            <a:pPr marL="190500" indent="-190500">
-              <a:spcBef>
-                <a:spcPts val="400"/>
-              </a:spcBef>
-              <a:spcAft>
-                <a:spcPts val="200"/>
-              </a:spcAft>
-            </a:pPr>
-            <a:r>
-              <a:rPr sz="1300">
-                <a:solidFill>
-                  <a:srgbClr val="3D5466"/>
-                </a:solidFill>
-                <a:latin typeface="Arial"/>
-              </a:rPr>
-              <a:t>▸  Eigenkapitalquote: Ø 18–24 % (niedriger als Industrie, weil arbeitsintensiv und wenig Anlageintensität)</a:t>
-            </a:r>
-          </a:p>
-          <a:p>
-            <a:pPr marL="190500" indent="-190500">
-              <a:spcBef>
-                <a:spcPts val="400"/>
-              </a:spcBef>
-              <a:spcAft>
-                <a:spcPts val="200"/>
-              </a:spcAft>
-            </a:pPr>
-            <a:r>
-              <a:rPr sz="1300">
-                <a:solidFill>
-                  <a:srgbClr val="3D5466"/>
-                </a:solidFill>
-                <a:latin typeface="Arial"/>
-              </a:rPr>
-              <a:t>▸  Finanzierungsbedarf: Kontokorrentlinie für saisonale Spitzen und Materialvorfinanzierung, Investitionskredite für Fahrzeuge, Maschinen und Werkzeuge, gelegentlich Betriebsgebäude</a:t>
-            </a:r>
-          </a:p>
-          <a:p>
-            <a:pPr marL="190500" indent="-190500">
-              <a:spcBef>
-                <a:spcPts val="400"/>
-              </a:spcBef>
-              <a:spcAft>
-                <a:spcPts val="200"/>
-              </a:spcAft>
-            </a:pPr>
-            <a:r>
-              <a:rPr sz="1300">
-                <a:solidFill>
-                  <a:srgbClr val="3D5466"/>
-                </a:solidFill>
-                <a:latin typeface="Arial"/>
-              </a:rPr>
-              <a:t>▸  Typische Risiken: Fachkräftemangel, Materialkostenvolatilität (Holz, Stahl, Kupfer), Auftragsschwankungen durch Baukonjunktur</a:t>
-            </a:r>
-          </a:p>
-          <a:p>
-            <a:pPr marL="190500" indent="-190500">
-              <a:spcBef>
-                <a:spcPts val="400"/>
-              </a:spcBef>
-              <a:spcAft>
-                <a:spcPts val="200"/>
-              </a:spcAft>
-            </a:pPr>
-            <a:r>
-              <a:rPr sz="1300">
-                <a:solidFill>
-                  <a:srgbClr val="3D5466"/>
-                </a:solidFill>
-                <a:latin typeface="Arial"/>
-              </a:rPr>
-              <a:t>▸  Was frage ich als Berater: "Wie gut sind Sie mit Aufträgen ausgelastet – haben Sie eine Warteliste?" / "Haben Sie genug qualifiziertes Personal, um Ihre Aufträge abzuarbeiten?"</a:t>
-            </a:r>
-          </a:p>
-          <a:p>
-            <a:pPr marL="190500" indent="-190500">
-              <a:spcBef>
-                <a:spcPts val="400"/>
-              </a:spcBef>
-              <a:spcAft>
-                <a:spcPts val="200"/>
-              </a:spcAft>
-            </a:pPr>
-            <a:r>
-              <a:rPr sz="1300">
-                <a:solidFill>
-                  <a:srgbClr val="3D5466"/>
-                </a:solidFill>
-                <a:latin typeface="Arial"/>
-              </a:rPr>
-              <a:t>▸  Branchenprofil B – Produzierendes Gewerbe / Maschinenbau</a:t>
-            </a:r>
-          </a:p>
-          <a:p>
-            <a:pPr marL="190500" indent="-190500">
-              <a:spcBef>
-                <a:spcPts val="400"/>
-              </a:spcBef>
-              <a:spcAft>
-                <a:spcPts val="200"/>
-              </a:spcAft>
-            </a:pPr>
-            <a:r>
-              <a:rPr sz="1300">
-                <a:solidFill>
-                  <a:srgbClr val="3D5466"/>
-                </a:solidFill>
-                <a:latin typeface="Arial"/>
-              </a:rPr>
-              <a:t>▸  Eigenkapitalquote: Ø 28–35 % (höher, weil hoher Anlagevermögensanteil)</a:t>
-            </a:r>
-          </a:p>
-          <a:p>
-            <a:pPr marL="190500" indent="-190500">
-              <a:spcBef>
-                <a:spcPts val="400"/>
-              </a:spcBef>
-              <a:spcAft>
-                <a:spcPts val="200"/>
-              </a:spcAft>
-            </a:pPr>
-            <a:r>
-              <a:rPr sz="1300">
-                <a:solidFill>
-                  <a:srgbClr val="3D5466"/>
-                </a:solidFill>
-                <a:latin typeface="Arial"/>
-              </a:rPr>
-              <a:t>▸  Finanzierungsbedarf: Investitionskredite für Maschinen und Anlagen (oft langfristig, 7–15 Jahre), Exportfinanzierung, Anzahlungsfinanzierung bei Großaufträgen, Betriebsmittelkredite</a:t>
-            </a:r>
-          </a:p>
-          <a:p>
-            <a:pPr marL="190500" indent="-190500">
-              <a:spcBef>
-                <a:spcPts val="400"/>
-              </a:spcBef>
-              <a:spcAft>
-                <a:spcPts val="200"/>
-              </a:spcAft>
-            </a:pPr>
-            <a:r>
-              <a:rPr sz="1300">
-                <a:solidFill>
-                  <a:srgbClr val="3D5466"/>
-                </a:solidFill>
-                <a:latin typeface="Arial"/>
-              </a:rPr>
-              <a:t>▸  Typische Risiken: Exportabhängigkeit (Wechselkurs, geopolitische Risiken), Energiekostenentwicklung, Lieferkettenstörungen</a:t>
+              <a:t>▸  Das 5-Fragen-Schema strukturiert den Analyseeinstieg in jedes KMU-Gespräch.</a:t>
             </a:r>
           </a:p>
         </p:txBody>
@@ -5262,7 +5232,7 @@
                 </a:solidFill>
                 <a:latin typeface="Arial"/>
               </a:rPr>
-              <a:t>Fünf-Fragen-Schema für den KMU-Beratungseinstieg</a:t>
+              <a:t>Das 5-Fragen-Schema für den KMU-Beratungseinstieg</a:t>
             </a:r>
           </a:p>
         </p:txBody>
@@ -5480,7 +5450,7 @@
             <a:avLst/>
           </a:prstGeom>
           <a:solidFill>
-            <a:srgbClr val="EDEDF3"/>
+            <a:srgbClr val="1F2C56"/>
           </a:solidFill>
           <a:ln>
             <a:noFill/>
@@ -5510,57 +5480,14 @@
       </p:sp>
       <p:sp>
         <p:nvSpPr>
-          <p:cNvPr id="3" name="Rectangle 2"/>
-          <p:cNvSpPr/>
-          <p:nvPr/>
-        </p:nvSpPr>
-        <p:spPr>
-          <a:xfrm>
-            <a:off x="0" y="0"/>
-            <a:ext cx="12188952" cy="50292"/>
-          </a:xfrm>
-          <a:prstGeom prst="rect">
-            <a:avLst/>
-          </a:prstGeom>
-          <a:solidFill>
-            <a:srgbClr val="1F2C56"/>
-          </a:solidFill>
-          <a:ln>
-            <a:noFill/>
-          </a:ln>
-        </p:spPr>
-        <p:style>
-          <a:lnRef idx="1">
-            <a:schemeClr val="accent1"/>
-          </a:lnRef>
-          <a:fillRef idx="3">
-            <a:schemeClr val="accent1"/>
-          </a:fillRef>
-          <a:effectRef idx="2">
-            <a:schemeClr val="accent1"/>
-          </a:effectRef>
-          <a:fontRef idx="minor">
-            <a:schemeClr val="lt1"/>
-          </a:fontRef>
-        </p:style>
-        <p:txBody>
-          <a:bodyPr rtlCol="0" anchor="ctr"/>
-          <a:lstStyle/>
-          <a:p>
-            <a:pPr algn="ctr"/>
-          </a:p>
-        </p:txBody>
-      </p:sp>
-      <p:sp>
-        <p:nvSpPr>
-          <p:cNvPr id="4" name="TextBox 3"/>
+          <p:cNvPr id="3" name="TextBox 2"/>
           <p:cNvSpPr txBox="1"/>
           <p:nvPr/>
         </p:nvSpPr>
         <p:spPr>
           <a:xfrm>
-            <a:off x="685800" y="109728"/>
-            <a:ext cx="10817352" cy="228600"/>
+            <a:off x="685800" y="2377440"/>
+            <a:ext cx="10817352" cy="365760"/>
           </a:xfrm>
           <a:prstGeom prst="rect">
             <a:avLst/>
@@ -5575,70 +5502,27 @@
           <a:p>
             <a:pPr algn="l"/>
             <a:r>
-              <a:rPr sz="750">
-                <a:solidFill>
-                  <a:srgbClr val="78808C"/>
+              <a:rPr sz="1200">
+                <a:solidFill>
+                  <a:srgbClr val="D9C089"/>
                 </a:solidFill>
                 <a:latin typeface="Consolas"/>
               </a:rPr>
-              <a:t>M06  ·  INHALT</a:t>
-            </a:r>
-          </a:p>
-        </p:txBody>
-      </p:sp>
-      <p:sp>
-        <p:nvSpPr>
-          <p:cNvPr id="5" name="Rectangle 4"/>
+              <a:t>FALLARBEIT</a:t>
+            </a:r>
+          </a:p>
+        </p:txBody>
+      </p:sp>
+      <p:sp>
+        <p:nvSpPr>
+          <p:cNvPr id="4" name="Rectangle 3"/>
           <p:cNvSpPr/>
           <p:nvPr/>
         </p:nvSpPr>
         <p:spPr>
           <a:xfrm>
-            <a:off x="0" y="1234440"/>
-            <a:ext cx="12188952" cy="12700"/>
-          </a:xfrm>
-          <a:prstGeom prst="rect">
-            <a:avLst/>
-          </a:prstGeom>
-          <a:solidFill>
-            <a:srgbClr val="D8DFE4"/>
-          </a:solidFill>
-          <a:ln>
-            <a:noFill/>
-          </a:ln>
-        </p:spPr>
-        <p:style>
-          <a:lnRef idx="1">
-            <a:schemeClr val="accent1"/>
-          </a:lnRef>
-          <a:fillRef idx="3">
-            <a:schemeClr val="accent1"/>
-          </a:fillRef>
-          <a:effectRef idx="2">
-            <a:schemeClr val="accent1"/>
-          </a:effectRef>
-          <a:fontRef idx="minor">
-            <a:schemeClr val="lt1"/>
-          </a:fontRef>
-        </p:style>
-        <p:txBody>
-          <a:bodyPr rtlCol="0" anchor="ctr"/>
-          <a:lstStyle/>
-          <a:p>
-            <a:pPr algn="ctr"/>
-          </a:p>
-        </p:txBody>
-      </p:sp>
-      <p:sp>
-        <p:nvSpPr>
-          <p:cNvPr id="6" name="Rectangle 5"/>
-          <p:cNvSpPr/>
-          <p:nvPr/>
-        </p:nvSpPr>
-        <p:spPr>
-          <a:xfrm>
-            <a:off x="685800" y="502920"/>
-            <a:ext cx="36576" cy="658368"/>
+            <a:off x="685800" y="2788920"/>
+            <a:ext cx="548640" cy="38100"/>
           </a:xfrm>
           <a:prstGeom prst="rect">
             <a:avLst/>
@@ -5674,14 +5558,14 @@
       </p:sp>
       <p:sp>
         <p:nvSpPr>
-          <p:cNvPr id="7" name="TextBox 6"/>
+          <p:cNvPr id="5" name="TextBox 4"/>
           <p:cNvSpPr txBox="1"/>
           <p:nvPr/>
         </p:nvSpPr>
         <p:spPr>
           <a:xfrm>
-            <a:off x="813816" y="502920"/>
-            <a:ext cx="10634472" cy="685800"/>
+            <a:off x="685800" y="3017520"/>
+            <a:ext cx="10817352" cy="1463040"/>
           </a:xfrm>
           <a:prstGeom prst="rect">
             <a:avLst/>
@@ -5696,27 +5580,27 @@
           <a:p>
             <a:pPr algn="l"/>
             <a:r>
-              <a:rPr sz="2400" b="1" i="0">
-                <a:solidFill>
-                  <a:srgbClr val="1F2C56"/>
+              <a:rPr sz="4000" b="1" i="0">
+                <a:solidFill>
+                  <a:srgbClr val="FFFFFF"/>
                 </a:solidFill>
                 <a:latin typeface="Arial"/>
               </a:rPr>
-              <a:t>Praxiscase: Bergmann Holzmanufaktur GmbH &amp; Co. KG</a:t>
-            </a:r>
-          </a:p>
-        </p:txBody>
-      </p:sp>
-      <p:sp>
-        <p:nvSpPr>
-          <p:cNvPr id="8" name="TextBox 7"/>
+              <a:t>Praxiscase Bergmann Holzmanufaktur</a:t>
+            </a:r>
+          </a:p>
+        </p:txBody>
+      </p:sp>
+      <p:sp>
+        <p:nvSpPr>
+          <p:cNvPr id="6" name="TextBox 5"/>
           <p:cNvSpPr txBox="1"/>
           <p:nvPr/>
         </p:nvSpPr>
         <p:spPr>
           <a:xfrm>
-            <a:off x="685800" y="1417320"/>
-            <a:ext cx="10817352" cy="4892040"/>
+            <a:off x="685800" y="4480560"/>
+            <a:ext cx="8653881" cy="1280160"/>
           </a:xfrm>
           <a:prstGeom prst="rect">
             <a:avLst/>
@@ -5729,193 +5613,29 @@
           </a:bodyPr>
           <a:lstStyle/>
           <a:p>
-            <a:pPr>
-              <a:spcBef>
-                <a:spcPts val="1000"/>
-              </a:spcBef>
-              <a:spcAft>
-                <a:spcPts val="200"/>
-              </a:spcAft>
-            </a:pPr>
-            <a:r>
-              <a:rPr sz="800" b="1">
-                <a:solidFill>
-                  <a:srgbClr val="78808C"/>
-                </a:solidFill>
-                <a:latin typeface="Consolas"/>
-              </a:rPr>
-              <a:t>FINANZDATEN (FIKTIV, PLAUSIBEL FÜR HOLZHANDWERK)</a:t>
-            </a:r>
-          </a:p>
-          <a:p>
-            <a:pPr marL="190500" indent="-190500">
-              <a:spcBef>
-                <a:spcPts val="400"/>
-              </a:spcBef>
-              <a:spcAft>
-                <a:spcPts val="200"/>
-              </a:spcAft>
-            </a:pPr>
-            <a:r>
-              <a:rPr sz="1300">
-                <a:solidFill>
-                  <a:srgbClr val="3D5466"/>
+            <a:pPr algn="l"/>
+            <a:r>
+              <a:rPr sz="1600" b="0" i="0">
+                <a:solidFill>
+                  <a:srgbClr val="C8D2E6"/>
                 </a:solidFill>
                 <a:latin typeface="Arial"/>
               </a:rPr>
-              <a:t>▸  *Branchenwerte Holzgewerbe / Tischlerhandwerk, Quelle: Deutsche Bundesbank, Unternehmensabschlussstatistik (Bundesbank, laufend )</a:t>
-            </a:r>
-          </a:p>
-          <a:p>
-            <a:pPr>
-              <a:spcBef>
-                <a:spcPts val="1000"/>
-              </a:spcBef>
-              <a:spcAft>
-                <a:spcPts val="200"/>
-              </a:spcAft>
-            </a:pPr>
-            <a:r>
-              <a:rPr sz="800" b="1">
-                <a:solidFill>
-                  <a:srgbClr val="78808C"/>
-                </a:solidFill>
-                <a:latin typeface="Consolas"/>
-              </a:rPr>
-              <a:t>AUFGABEN</a:t>
-            </a:r>
-          </a:p>
-          <a:p>
-            <a:pPr marL="190500" indent="-190500">
-              <a:spcBef>
-                <a:spcPts val="400"/>
-              </a:spcBef>
-              <a:spcAft>
-                <a:spcPts val="200"/>
-              </a:spcAft>
-            </a:pPr>
-            <a:r>
-              <a:rPr sz="1300">
-                <a:solidFill>
-                  <a:srgbClr val="3D5466"/>
-                </a:solidFill>
-                <a:latin typeface="Arial"/>
-              </a:rPr>
-              <a:t>▸  Aufgabe 1 – Klassifizierung (LZ-1):</a:t>
-            </a:r>
-          </a:p>
-          <a:p>
-            <a:pPr marL="190500" indent="-190500">
-              <a:spcBef>
-                <a:spcPts val="400"/>
-              </a:spcBef>
-              <a:spcAft>
-                <a:spcPts val="200"/>
-              </a:spcAft>
-            </a:pPr>
-            <a:r>
-              <a:rPr sz="1300">
-                <a:solidFill>
-                  <a:srgbClr val="3D5466"/>
-                </a:solidFill>
-                <a:latin typeface="Arial"/>
-              </a:rPr>
-              <a:t>▸  Aufgabe 2 – Typologisierung und Risikofelder (LZ-2/LZ-3):</a:t>
-            </a:r>
-          </a:p>
-          <a:p>
-            <a:pPr marL="190500" indent="-190500">
-              <a:spcBef>
-                <a:spcPts val="400"/>
-              </a:spcBef>
-              <a:spcAft>
-                <a:spcPts val="200"/>
-              </a:spcAft>
-            </a:pPr>
-            <a:r>
-              <a:rPr sz="1300">
-                <a:solidFill>
-                  <a:srgbClr val="3D5466"/>
-                </a:solidFill>
-                <a:latin typeface="Arial"/>
-              </a:rPr>
-              <a:t>▸  Aufgabe 3 – 5-Fragen-Schema anwenden (LZ-4):</a:t>
-            </a:r>
-          </a:p>
-          <a:p>
-            <a:pPr marL="190500" indent="-190500">
-              <a:spcBef>
-                <a:spcPts val="400"/>
-              </a:spcBef>
-              <a:spcAft>
-                <a:spcPts val="200"/>
-              </a:spcAft>
-            </a:pPr>
-            <a:r>
-              <a:rPr sz="1300">
-                <a:solidFill>
-                  <a:srgbClr val="3D5466"/>
-                </a:solidFill>
-                <a:latin typeface="Arial"/>
-              </a:rPr>
-              <a:t>▸  Aufgabe 4 – Kreditvorbereitung: KK-Analyse (LZ-3):</a:t>
-            </a:r>
-          </a:p>
-        </p:txBody>
-      </p:sp>
-      <p:sp>
-        <p:nvSpPr>
-          <p:cNvPr id="9" name="Rectangle 8"/>
-          <p:cNvSpPr/>
-          <p:nvPr/>
-        </p:nvSpPr>
-        <p:spPr>
-          <a:xfrm>
-            <a:off x="0" y="6510528"/>
-            <a:ext cx="12188952" cy="347472"/>
-          </a:xfrm>
-          <a:prstGeom prst="rect">
-            <a:avLst/>
-          </a:prstGeom>
-          <a:solidFill>
-            <a:srgbClr val="0A1937"/>
-          </a:solidFill>
-          <a:ln>
-            <a:noFill/>
-          </a:ln>
-        </p:spPr>
-        <p:style>
-          <a:lnRef idx="1">
-            <a:schemeClr val="accent1"/>
-          </a:lnRef>
-          <a:fillRef idx="3">
-            <a:schemeClr val="accent1"/>
-          </a:fillRef>
-          <a:effectRef idx="2">
-            <a:schemeClr val="accent1"/>
-          </a:effectRef>
-          <a:fontRef idx="minor">
-            <a:schemeClr val="lt1"/>
-          </a:fontRef>
-        </p:style>
-        <p:txBody>
-          <a:bodyPr rtlCol="0" anchor="ctr"/>
-          <a:lstStyle/>
-          <a:p>
-            <a:pPr algn="ctr"/>
-          </a:p>
-        </p:txBody>
-      </p:sp>
-      <p:sp>
-        <p:nvSpPr>
-          <p:cNvPr id="10" name="TextBox 9"/>
+              <a:t>Die KMU-Perspektive auf einen echten Handwerksbetrieb anwenden.</a:t>
+            </a:r>
+          </a:p>
+        </p:txBody>
+      </p:sp>
+      <p:sp>
+        <p:nvSpPr>
+          <p:cNvPr id="7" name="TextBox 6"/>
           <p:cNvSpPr txBox="1"/>
           <p:nvPr/>
         </p:nvSpPr>
         <p:spPr>
           <a:xfrm>
-            <a:off x="685800" y="6583680"/>
-            <a:ext cx="6490411" cy="256032"/>
+            <a:off x="685800" y="6355080"/>
+            <a:ext cx="10817352" cy="274320"/>
           </a:xfrm>
           <a:prstGeom prst="rect">
             <a:avLst/>
@@ -5932,7 +5652,7 @@
             <a:r>
               <a:rPr sz="700">
                 <a:solidFill>
-                  <a:srgbClr val="A0B4D2"/>
+                  <a:srgbClr val="8CA0C3"/>
                 </a:solidFill>
                 <a:latin typeface="Consolas"/>
               </a:rPr>
@@ -6110,7 +5830,7 @@
                 </a:solidFill>
                 <a:latin typeface="Arial"/>
               </a:rPr>
-              <a:t>Praxiscase: Bergmann Holzmanufaktur GmbH &amp; Co. KG</a:t>
+              <a:t>Bergmann Holzmanufaktur: Kennzahlen im Branchenvergleich</a:t>
             </a:r>
           </a:p>
         </p:txBody>
@@ -6168,7 +5888,7 @@
         </p:nvGraphicFramePr>
         <p:xfrm>
           <a:off x="685800" y="1417320"/>
-          <a:ext cx="10817352" cy="2304288"/>
+          <a:ext cx="10817352" cy="1920240"/>
         </p:xfrm>
         <a:graphic>
           <a:graphicData uri="http://schemas.openxmlformats.org/drawingml/2006/table">
@@ -6238,7 +5958,7 @@
                           </a:solidFill>
                           <a:latin typeface="Arial"/>
                         </a:rPr>
-                        <a:t>Branchenwert*</a:t>
+                        <a:t>Branchenwert</a:t>
                       </a:r>
                     </a:p>
                   </a:txBody>
@@ -6247,6 +5967,118 @@
                       <a:srgbClr val="1F2C56"/>
                     </a:solidFill>
                   </a:tcPr>
+                </a:tc>
+              </a:tr>
+              <a:tr h="384048">
+                <a:tc>
+                  <a:txBody>
+                    <a:bodyPr/>
+                    <a:lstStyle/>
+                    <a:p>
+                      <a:r>
+                        <a:rPr sz="1050">
+                          <a:solidFill>
+                            <a:srgbClr val="3D5466"/>
+                          </a:solidFill>
+                          <a:latin typeface="Arial"/>
+                        </a:rPr>
+                        <a:t>Jahresumsatz</a:t>
+                      </a:r>
+                    </a:p>
+                  </a:txBody>
+                  <a:tcPr/>
+                </a:tc>
+                <a:tc>
+                  <a:txBody>
+                    <a:bodyPr/>
+                    <a:lstStyle/>
+                    <a:p>
+                      <a:r>
+                        <a:rPr sz="1050">
+                          <a:solidFill>
+                            <a:srgbClr val="3D5466"/>
+                          </a:solidFill>
+                          <a:latin typeface="Arial"/>
+                        </a:rPr>
+                        <a:t>1,8 Mio. EUR</a:t>
+                      </a:r>
+                    </a:p>
+                  </a:txBody>
+                  <a:tcPr/>
+                </a:tc>
+                <a:tc>
+                  <a:txBody>
+                    <a:bodyPr/>
+                    <a:lstStyle/>
+                    <a:p>
+                      <a:r>
+                        <a:rPr sz="1050">
+                          <a:solidFill>
+                            <a:srgbClr val="3D5466"/>
+                          </a:solidFill>
+                          <a:latin typeface="Arial"/>
+                        </a:rPr>
+                        <a:t>—</a:t>
+                      </a:r>
+                    </a:p>
+                  </a:txBody>
+                  <a:tcPr/>
+                </a:tc>
+              </a:tr>
+              <a:tr h="384048">
+                <a:tc>
+                  <a:txBody>
+                    <a:bodyPr/>
+                    <a:lstStyle/>
+                    <a:p>
+                      <a:r>
+                        <a:rPr sz="1050">
+                          <a:solidFill>
+                            <a:srgbClr val="3D5466"/>
+                          </a:solidFill>
+                          <a:latin typeface="Arial"/>
+                        </a:rPr>
+                        <a:t>Beschäftigte</a:t>
+                      </a:r>
+                    </a:p>
+                  </a:txBody>
+                  <a:tcPr/>
+                </a:tc>
+                <a:tc>
+                  <a:txBody>
+                    <a:bodyPr/>
+                    <a:lstStyle/>
+                    <a:p>
+                      <a:r>
+                        <a:rPr sz="1050">
+                          <a:solidFill>
+                            <a:srgbClr val="3D5466"/>
+                          </a:solidFill>
+                          <a:latin typeface="Arial"/>
+                        </a:rPr>
+                        <a:t>8</a:t>
+                      </a:r>
+                    </a:p>
+                  </a:txBody>
+                  <a:tcPr/>
+                </a:tc>
+                <a:tc>
+                  <a:txBody>
+                    <a:bodyPr/>
+                    <a:lstStyle/>
+                    <a:p>
+                      <a:r>
+                        <a:rPr sz="1050">
+                          <a:solidFill>
+                            <a:srgbClr val="3D5466"/>
+                          </a:solidFill>
+                          <a:latin typeface="Arial"/>
+                        </a:rPr>
+                        <a:t>—</a:t>
+                      </a:r>
+                    </a:p>
+                  </a:txBody>
+                  <a:tcPr/>
                 </a:tc>
               </a:tr>
               <a:tr h="384048">
@@ -6318,119 +6150,7 @@
                           </a:solidFill>
                           <a:latin typeface="Arial"/>
                         </a:rPr>
-                        <a:t>Jahresumsatz</a:t>
-                      </a:r>
-                    </a:p>
-                  </a:txBody>
-                  <a:tcPr/>
-                </a:tc>
-                <a:tc>
-                  <a:txBody>
-                    <a:bodyPr/>
-                    <a:lstStyle/>
-                    <a:p>
-                      <a:r>
-                        <a:rPr sz="1050">
-                          <a:solidFill>
-                            <a:srgbClr val="3D5466"/>
-                          </a:solidFill>
-                          <a:latin typeface="Arial"/>
-                        </a:rPr>
-                        <a:t>1,8 Mio. EUR</a:t>
-                      </a:r>
-                    </a:p>
-                  </a:txBody>
-                  <a:tcPr/>
-                </a:tc>
-                <a:tc>
-                  <a:txBody>
-                    <a:bodyPr/>
-                    <a:lstStyle/>
-                    <a:p>
-                      <a:r>
-                        <a:rPr sz="1050">
-                          <a:solidFill>
-                            <a:srgbClr val="3D5466"/>
-                          </a:solidFill>
-                          <a:latin typeface="Arial"/>
-                        </a:rPr>
-                        <a:t>–</a:t>
-                      </a:r>
-                    </a:p>
-                  </a:txBody>
-                  <a:tcPr/>
-                </a:tc>
-              </a:tr>
-              <a:tr h="384048">
-                <a:tc>
-                  <a:txBody>
-                    <a:bodyPr/>
-                    <a:lstStyle/>
-                    <a:p>
-                      <a:r>
-                        <a:rPr sz="1050">
-                          <a:solidFill>
-                            <a:srgbClr val="3D5466"/>
-                          </a:solidFill>
-                          <a:latin typeface="Arial"/>
-                        </a:rPr>
-                        <a:t>Beschäftigte</a:t>
-                      </a:r>
-                    </a:p>
-                  </a:txBody>
-                  <a:tcPr/>
-                </a:tc>
-                <a:tc>
-                  <a:txBody>
-                    <a:bodyPr/>
-                    <a:lstStyle/>
-                    <a:p>
-                      <a:r>
-                        <a:rPr sz="1050">
-                          <a:solidFill>
-                            <a:srgbClr val="3D5466"/>
-                          </a:solidFill>
-                          <a:latin typeface="Arial"/>
-                        </a:rPr>
-                        <a:t>8</a:t>
-                      </a:r>
-                    </a:p>
-                  </a:txBody>
-                  <a:tcPr/>
-                </a:tc>
-                <a:tc>
-                  <a:txBody>
-                    <a:bodyPr/>
-                    <a:lstStyle/>
-                    <a:p>
-                      <a:r>
-                        <a:rPr sz="1050">
-                          <a:solidFill>
-                            <a:srgbClr val="3D5466"/>
-                          </a:solidFill>
-                          <a:latin typeface="Arial"/>
-                        </a:rPr>
-                        <a:t>–</a:t>
-                      </a:r>
-                    </a:p>
-                  </a:txBody>
-                  <a:tcPr/>
-                </a:tc>
-              </a:tr>
-              <a:tr h="384048">
-                <a:tc>
-                  <a:txBody>
-                    <a:bodyPr/>
-                    <a:lstStyle/>
-                    <a:p>
-                      <a:r>
-                        <a:rPr sz="1050">
-                          <a:solidFill>
-                            <a:srgbClr val="3D5466"/>
-                          </a:solidFill>
-                          <a:latin typeface="Arial"/>
-                        </a:rPr>
-                        <a:t>Umsatzrendite (vor Steuern)</a:t>
+                        <a:t>Umsatzrendite</a:t>
                       </a:r>
                     </a:p>
                   </a:txBody>
@@ -6473,62 +6193,6 @@
                   <a:tcPr/>
                 </a:tc>
               </a:tr>
-              <a:tr h="384048">
-                <a:tc>
-                  <a:txBody>
-                    <a:bodyPr/>
-                    <a:lstStyle/>
-                    <a:p>
-                      <a:r>
-                        <a:rPr sz="1050">
-                          <a:solidFill>
-                            <a:srgbClr val="3D5466"/>
-                          </a:solidFill>
-                          <a:latin typeface="Arial"/>
-                        </a:rPr>
-                        <a:t>Fremdkapitalquote</a:t>
-                      </a:r>
-                    </a:p>
-                  </a:txBody>
-                  <a:tcPr/>
-                </a:tc>
-                <a:tc>
-                  <a:txBody>
-                    <a:bodyPr/>
-                    <a:lstStyle/>
-                    <a:p>
-                      <a:r>
-                        <a:rPr sz="1050">
-                          <a:solidFill>
-                            <a:srgbClr val="3D5466"/>
-                          </a:solidFill>
-                          <a:latin typeface="Arial"/>
-                        </a:rPr>
-                        <a:t>79 %</a:t>
-                      </a:r>
-                    </a:p>
-                  </a:txBody>
-                  <a:tcPr/>
-                </a:tc>
-                <a:tc>
-                  <a:txBody>
-                    <a:bodyPr/>
-                    <a:lstStyle/>
-                    <a:p>
-                      <a:r>
-                        <a:rPr sz="1050">
-                          <a:solidFill>
-                            <a:srgbClr val="3D5466"/>
-                          </a:solidFill>
-                          <a:latin typeface="Arial"/>
-                        </a:rPr>
-                        <a:t>Ø 76–82 %</a:t>
-                      </a:r>
-                    </a:p>
-                  </a:txBody>
-                  <a:tcPr/>
-                </a:tc>
-              </a:tr>
             </a:tbl>
           </a:graphicData>
         </a:graphic>
@@ -6780,7 +6444,7 @@
                 </a:solidFill>
                 <a:latin typeface="Consolas"/>
               </a:rPr>
-              <a:t>M06  ·  INHALT</a:t>
+              <a:t>M06  ·  ARBEITSBLATT</a:t>
             </a:r>
           </a:p>
         </p:txBody>
@@ -6901,7 +6565,7 @@
                 </a:solidFill>
                 <a:latin typeface="Arial"/>
               </a:rPr>
-              <a:t>Reflexionsfragen</a:t>
+              <a:t>Praxiscase Bergmann bearbeiten</a:t>
             </a:r>
           </a:p>
         </p:txBody>
@@ -6914,8 +6578,8 @@
         </p:nvSpPr>
         <p:spPr>
           <a:xfrm>
-            <a:off x="685800" y="1417320"/>
-            <a:ext cx="10817352" cy="4892040"/>
+            <a:off x="685800" y="1554480"/>
+            <a:ext cx="10817352" cy="3840480"/>
           </a:xfrm>
           <a:prstGeom prst="rect">
             <a:avLst/>
@@ -6923,7 +6587,7 @@
           <a:noFill/>
         </p:spPr>
         <p:txBody>
-          <a:bodyPr wrap="square" anchor="ctr">
+          <a:bodyPr wrap="square">
             <a:spAutoFit/>
           </a:bodyPr>
           <a:lstStyle/>
@@ -6937,13 +6601,13 @@
               </a:spcAft>
             </a:pPr>
             <a:r>
-              <a:rPr sz="1300">
+              <a:rPr sz="1400">
                 <a:solidFill>
                   <a:srgbClr val="3D5466"/>
                 </a:solidFill>
                 <a:latin typeface="Arial"/>
               </a:rPr>
-              <a:t>▸  Verstehen (Bloom 2): Warum ist die Inhaberabhängigkeit bei einem Handwerksbetrieb mit 8 Mitarbeitern ein strukturell höheres Risiko als bei einem Produktionsbetrieb mit 80 Mitarbeitern – was verändert sich mit zunehmender Betriebsgröße strukturell?</a:t>
+              <a:t>▸  Analysieren Sie die Bergmann Holzmanufaktur mit dem 5-Fragen-Schema (AB-1).</a:t>
             </a:r>
           </a:p>
           <a:p>
@@ -6956,13 +6620,13 @@
               </a:spcAft>
             </a:pPr>
             <a:r>
-              <a:rPr sz="1300">
+              <a:rPr sz="1400">
                 <a:solidFill>
                   <a:srgbClr val="3D5466"/>
                 </a:solidFill>
                 <a:latin typeface="Arial"/>
               </a:rPr>
-              <a:t>▸  Anwenden (Bloom 3): Ein Kunde sagt Ihnen: "Wir sind kein KMU, wir sind ein mittelständisches Unternehmen." Wie reagieren Sie – was ist der begriffliche Unterschied, und was sagt das über die Selbstwahrnehmung des Inhabers?</a:t>
+              <a:t>▸  Ordnen Sie die Kennzahlen in den Branchenkontext ein.</a:t>
             </a:r>
           </a:p>
           <a:p>
@@ -6975,13 +6639,908 @@
               </a:spcAft>
             </a:pPr>
             <a:r>
-              <a:rPr sz="1300">
+              <a:rPr sz="1400">
                 <a:solidFill>
                   <a:srgbClr val="3D5466"/>
                 </a:solidFill>
                 <a:latin typeface="Arial"/>
               </a:rPr>
-              <a:t>▸  Anwenden (Bloom 3): Bergmann Holzmanufaktur hat eine EK-Quote von 21 % – genau im Branchenmittel. Ein Kollege sagt: "Das ist unauffällig, kein Handlungsbedarf." Welche Informationen fehlen für eine vollständige Einschätzung? Was würden Sie als nächstes klären?</a:t>
+              <a:t>▸  Identifizieren Sie die strukturellen Risiken und den passenden Verbundimpuls.</a:t>
+            </a:r>
+          </a:p>
+        </p:txBody>
+      </p:sp>
+      <p:sp>
+        <p:nvSpPr>
+          <p:cNvPr id="9" name="Rectangle 8"/>
+          <p:cNvSpPr/>
+          <p:nvPr/>
+        </p:nvSpPr>
+        <p:spPr>
+          <a:xfrm>
+            <a:off x="685800" y="5486400"/>
+            <a:ext cx="10817352" cy="640080"/>
+          </a:xfrm>
+          <a:prstGeom prst="rect">
+            <a:avLst/>
+          </a:prstGeom>
+          <a:solidFill>
+            <a:srgbClr val="1F2C56"/>
+          </a:solidFill>
+          <a:ln>
+            <a:noFill/>
+          </a:ln>
+        </p:spPr>
+        <p:style>
+          <a:lnRef idx="1">
+            <a:schemeClr val="accent1"/>
+          </a:lnRef>
+          <a:fillRef idx="3">
+            <a:schemeClr val="accent1"/>
+          </a:fillRef>
+          <a:effectRef idx="2">
+            <a:schemeClr val="accent1"/>
+          </a:effectRef>
+          <a:fontRef idx="minor">
+            <a:schemeClr val="lt1"/>
+          </a:fontRef>
+        </p:style>
+        <p:txBody>
+          <a:bodyPr rtlCol="0" anchor="ctr"/>
+          <a:lstStyle/>
+          <a:p>
+            <a:pPr algn="ctr"/>
+          </a:p>
+        </p:txBody>
+      </p:sp>
+      <p:sp>
+        <p:nvSpPr>
+          <p:cNvPr id="10" name="TextBox 9"/>
+          <p:cNvSpPr txBox="1"/>
+          <p:nvPr/>
+        </p:nvSpPr>
+        <p:spPr>
+          <a:xfrm>
+            <a:off x="868680" y="5596128"/>
+            <a:ext cx="10451592" cy="457200"/>
+          </a:xfrm>
+          <a:prstGeom prst="rect">
+            <a:avLst/>
+          </a:prstGeom>
+          <a:noFill/>
+        </p:spPr>
+        <p:txBody>
+          <a:bodyPr wrap="square">
+            <a:spAutoFit/>
+          </a:bodyPr>
+          <a:lstStyle/>
+          <a:p>
+            <a:pPr algn="l"/>
+            <a:r>
+              <a:rPr sz="1300" b="1" i="0">
+                <a:solidFill>
+                  <a:srgbClr val="FFFFFF"/>
+                </a:solidFill>
+                <a:latin typeface="Arial"/>
+              </a:rPr>
+              <a:t>→  Bearbeitung im Teilnehmer-Workbook (Arbeitsblatt mit Ausfüllfeldern)</a:t>
+            </a:r>
+          </a:p>
+        </p:txBody>
+      </p:sp>
+      <p:sp>
+        <p:nvSpPr>
+          <p:cNvPr id="11" name="Rectangle 10"/>
+          <p:cNvSpPr/>
+          <p:nvPr/>
+        </p:nvSpPr>
+        <p:spPr>
+          <a:xfrm>
+            <a:off x="0" y="6510528"/>
+            <a:ext cx="12188952" cy="347472"/>
+          </a:xfrm>
+          <a:prstGeom prst="rect">
+            <a:avLst/>
+          </a:prstGeom>
+          <a:solidFill>
+            <a:srgbClr val="0A1937"/>
+          </a:solidFill>
+          <a:ln>
+            <a:noFill/>
+          </a:ln>
+        </p:spPr>
+        <p:style>
+          <a:lnRef idx="1">
+            <a:schemeClr val="accent1"/>
+          </a:lnRef>
+          <a:fillRef idx="3">
+            <a:schemeClr val="accent1"/>
+          </a:fillRef>
+          <a:effectRef idx="2">
+            <a:schemeClr val="accent1"/>
+          </a:effectRef>
+          <a:fontRef idx="minor">
+            <a:schemeClr val="lt1"/>
+          </a:fontRef>
+        </p:style>
+        <p:txBody>
+          <a:bodyPr rtlCol="0" anchor="ctr"/>
+          <a:lstStyle/>
+          <a:p>
+            <a:pPr algn="ctr"/>
+          </a:p>
+        </p:txBody>
+      </p:sp>
+      <p:sp>
+        <p:nvSpPr>
+          <p:cNvPr id="12" name="TextBox 11"/>
+          <p:cNvSpPr txBox="1"/>
+          <p:nvPr/>
+        </p:nvSpPr>
+        <p:spPr>
+          <a:xfrm>
+            <a:off x="685800" y="6583680"/>
+            <a:ext cx="6490411" cy="256032"/>
+          </a:xfrm>
+          <a:prstGeom prst="rect">
+            <a:avLst/>
+          </a:prstGeom>
+          <a:noFill/>
+        </p:spPr>
+        <p:txBody>
+          <a:bodyPr wrap="none">
+            <a:spAutoFit/>
+          </a:bodyPr>
+          <a:lstStyle/>
+          <a:p>
+            <a:pPr algn="l"/>
+            <a:r>
+              <a:rPr sz="700">
+                <a:solidFill>
+                  <a:srgbClr val="A0B4D2"/>
+                </a:solidFill>
+                <a:latin typeface="Consolas"/>
+              </a:rPr>
+              <a:t>FKB Campus  ·  M06</a:t>
+            </a:r>
+          </a:p>
+        </p:txBody>
+      </p:sp>
+    </p:spTree>
+  </p:cSld>
+  <p:clrMapOvr>
+    <a:masterClrMapping/>
+  </p:clrMapOvr>
+</p:sld>
+</file>
+
+<file path=ppt/slides/slide15.xml><?xml version="1.0" encoding="utf-8"?>
+<p:sld xmlns:a="http://schemas.openxmlformats.org/drawingml/2006/main" xmlns:p="http://schemas.openxmlformats.org/presentationml/2006/main" xmlns:r="http://schemas.openxmlformats.org/officeDocument/2006/relationships">
+  <p:cSld>
+    <p:spTree>
+      <p:nvGrpSpPr>
+        <p:cNvPr id="1" name=""/>
+        <p:cNvGrpSpPr/>
+        <p:nvPr/>
+      </p:nvGrpSpPr>
+      <p:grpSpPr/>
+      <p:sp>
+        <p:nvSpPr>
+          <p:cNvPr id="2" name="Rectangle 1"/>
+          <p:cNvSpPr/>
+          <p:nvPr/>
+        </p:nvSpPr>
+        <p:spPr>
+          <a:xfrm>
+            <a:off x="0" y="0"/>
+            <a:ext cx="12188952" cy="6858000"/>
+          </a:xfrm>
+          <a:prstGeom prst="rect">
+            <a:avLst/>
+          </a:prstGeom>
+          <a:solidFill>
+            <a:srgbClr val="EDEDF3"/>
+          </a:solidFill>
+          <a:ln>
+            <a:noFill/>
+          </a:ln>
+        </p:spPr>
+        <p:style>
+          <a:lnRef idx="1">
+            <a:schemeClr val="accent1"/>
+          </a:lnRef>
+          <a:fillRef idx="3">
+            <a:schemeClr val="accent1"/>
+          </a:fillRef>
+          <a:effectRef idx="2">
+            <a:schemeClr val="accent1"/>
+          </a:effectRef>
+          <a:fontRef idx="minor">
+            <a:schemeClr val="lt1"/>
+          </a:fontRef>
+        </p:style>
+        <p:txBody>
+          <a:bodyPr rtlCol="0" anchor="ctr"/>
+          <a:lstStyle/>
+          <a:p>
+            <a:pPr algn="ctr"/>
+          </a:p>
+        </p:txBody>
+      </p:sp>
+      <p:sp>
+        <p:nvSpPr>
+          <p:cNvPr id="3" name="Rectangle 2"/>
+          <p:cNvSpPr/>
+          <p:nvPr/>
+        </p:nvSpPr>
+        <p:spPr>
+          <a:xfrm>
+            <a:off x="0" y="0"/>
+            <a:ext cx="12188952" cy="50292"/>
+          </a:xfrm>
+          <a:prstGeom prst="rect">
+            <a:avLst/>
+          </a:prstGeom>
+          <a:solidFill>
+            <a:srgbClr val="1F2C56"/>
+          </a:solidFill>
+          <a:ln>
+            <a:noFill/>
+          </a:ln>
+        </p:spPr>
+        <p:style>
+          <a:lnRef idx="1">
+            <a:schemeClr val="accent1"/>
+          </a:lnRef>
+          <a:fillRef idx="3">
+            <a:schemeClr val="accent1"/>
+          </a:fillRef>
+          <a:effectRef idx="2">
+            <a:schemeClr val="accent1"/>
+          </a:effectRef>
+          <a:fontRef idx="minor">
+            <a:schemeClr val="lt1"/>
+          </a:fontRef>
+        </p:style>
+        <p:txBody>
+          <a:bodyPr rtlCol="0" anchor="ctr"/>
+          <a:lstStyle/>
+          <a:p>
+            <a:pPr algn="ctr"/>
+          </a:p>
+        </p:txBody>
+      </p:sp>
+      <p:sp>
+        <p:nvSpPr>
+          <p:cNvPr id="4" name="TextBox 3"/>
+          <p:cNvSpPr txBox="1"/>
+          <p:nvPr/>
+        </p:nvSpPr>
+        <p:spPr>
+          <a:xfrm>
+            <a:off x="685800" y="109728"/>
+            <a:ext cx="10817352" cy="228600"/>
+          </a:xfrm>
+          <a:prstGeom prst="rect">
+            <a:avLst/>
+          </a:prstGeom>
+          <a:noFill/>
+        </p:spPr>
+        <p:txBody>
+          <a:bodyPr wrap="none">
+            <a:spAutoFit/>
+          </a:bodyPr>
+          <a:lstStyle/>
+          <a:p>
+            <a:pPr algn="l"/>
+            <a:r>
+              <a:rPr sz="750">
+                <a:solidFill>
+                  <a:srgbClr val="78808C"/>
+                </a:solidFill>
+                <a:latin typeface="Consolas"/>
+              </a:rPr>
+              <a:t>M06  ·  INHALT</a:t>
+            </a:r>
+          </a:p>
+        </p:txBody>
+      </p:sp>
+      <p:sp>
+        <p:nvSpPr>
+          <p:cNvPr id="5" name="Rectangle 4"/>
+          <p:cNvSpPr/>
+          <p:nvPr/>
+        </p:nvSpPr>
+        <p:spPr>
+          <a:xfrm>
+            <a:off x="0" y="1234440"/>
+            <a:ext cx="12188952" cy="12700"/>
+          </a:xfrm>
+          <a:prstGeom prst="rect">
+            <a:avLst/>
+          </a:prstGeom>
+          <a:solidFill>
+            <a:srgbClr val="D8DFE4"/>
+          </a:solidFill>
+          <a:ln>
+            <a:noFill/>
+          </a:ln>
+        </p:spPr>
+        <p:style>
+          <a:lnRef idx="1">
+            <a:schemeClr val="accent1"/>
+          </a:lnRef>
+          <a:fillRef idx="3">
+            <a:schemeClr val="accent1"/>
+          </a:fillRef>
+          <a:effectRef idx="2">
+            <a:schemeClr val="accent1"/>
+          </a:effectRef>
+          <a:fontRef idx="minor">
+            <a:schemeClr val="lt1"/>
+          </a:fontRef>
+        </p:style>
+        <p:txBody>
+          <a:bodyPr rtlCol="0" anchor="ctr"/>
+          <a:lstStyle/>
+          <a:p>
+            <a:pPr algn="ctr"/>
+          </a:p>
+        </p:txBody>
+      </p:sp>
+      <p:sp>
+        <p:nvSpPr>
+          <p:cNvPr id="6" name="Rectangle 5"/>
+          <p:cNvSpPr/>
+          <p:nvPr/>
+        </p:nvSpPr>
+        <p:spPr>
+          <a:xfrm>
+            <a:off x="685800" y="502920"/>
+            <a:ext cx="36576" cy="658368"/>
+          </a:xfrm>
+          <a:prstGeom prst="rect">
+            <a:avLst/>
+          </a:prstGeom>
+          <a:solidFill>
+            <a:srgbClr val="D9C089"/>
+          </a:solidFill>
+          <a:ln>
+            <a:noFill/>
+          </a:ln>
+        </p:spPr>
+        <p:style>
+          <a:lnRef idx="1">
+            <a:schemeClr val="accent1"/>
+          </a:lnRef>
+          <a:fillRef idx="3">
+            <a:schemeClr val="accent1"/>
+          </a:fillRef>
+          <a:effectRef idx="2">
+            <a:schemeClr val="accent1"/>
+          </a:effectRef>
+          <a:fontRef idx="minor">
+            <a:schemeClr val="lt1"/>
+          </a:fontRef>
+        </p:style>
+        <p:txBody>
+          <a:bodyPr rtlCol="0" anchor="ctr"/>
+          <a:lstStyle/>
+          <a:p>
+            <a:pPr algn="ctr"/>
+          </a:p>
+        </p:txBody>
+      </p:sp>
+      <p:sp>
+        <p:nvSpPr>
+          <p:cNvPr id="7" name="TextBox 6"/>
+          <p:cNvSpPr txBox="1"/>
+          <p:nvPr/>
+        </p:nvSpPr>
+        <p:spPr>
+          <a:xfrm>
+            <a:off x="813816" y="502920"/>
+            <a:ext cx="10634472" cy="685800"/>
+          </a:xfrm>
+          <a:prstGeom prst="rect">
+            <a:avLst/>
+          </a:prstGeom>
+          <a:noFill/>
+        </p:spPr>
+        <p:txBody>
+          <a:bodyPr wrap="square">
+            <a:spAutoFit/>
+          </a:bodyPr>
+          <a:lstStyle/>
+          <a:p>
+            <a:pPr algn="l"/>
+            <a:r>
+              <a:rPr sz="2400" b="1" i="0">
+                <a:solidFill>
+                  <a:srgbClr val="1F2C56"/>
+                </a:solidFill>
+                <a:latin typeface="Arial"/>
+              </a:rPr>
+              <a:t>Prinzip dieses Moduls</a:t>
+            </a:r>
+          </a:p>
+        </p:txBody>
+      </p:sp>
+      <p:sp>
+        <p:nvSpPr>
+          <p:cNvPr id="8" name="TextBox 7"/>
+          <p:cNvSpPr txBox="1"/>
+          <p:nvPr/>
+        </p:nvSpPr>
+        <p:spPr>
+          <a:xfrm>
+            <a:off x="685800" y="1417320"/>
+            <a:ext cx="10817352" cy="4892040"/>
+          </a:xfrm>
+          <a:prstGeom prst="rect">
+            <a:avLst/>
+          </a:prstGeom>
+          <a:noFill/>
+        </p:spPr>
+        <p:txBody>
+          <a:bodyPr wrap="square" anchor="ctr">
+            <a:spAutoFit/>
+          </a:bodyPr>
+          <a:lstStyle/>
+          <a:p>
+            <a:pPr marL="177800" indent="-177800">
+              <a:spcBef>
+                <a:spcPts val="600"/>
+              </a:spcBef>
+              <a:spcAft>
+                <a:spcPts val="200"/>
+              </a:spcAft>
+            </a:pPr>
+            <a:r>
+              <a:rPr sz="1200" i="1">
+                <a:solidFill>
+                  <a:srgbClr val="3D5466"/>
+                </a:solidFill>
+                <a:latin typeface="Arial"/>
+              </a:rPr>
+              <a:t>→  Beim Mittelständler sind Unternehmen und Unternehmer nicht zu trennen.</a:t>
+            </a:r>
+          </a:p>
+          <a:p>
+            <a:pPr marL="190500" indent="-190500">
+              <a:spcBef>
+                <a:spcPts val="400"/>
+              </a:spcBef>
+              <a:spcAft>
+                <a:spcPts val="200"/>
+              </a:spcAft>
+            </a:pPr>
+            <a:r>
+              <a:rPr sz="1300">
+                <a:solidFill>
+                  <a:srgbClr val="3D5466"/>
+                </a:solidFill>
+                <a:latin typeface="Arial"/>
+              </a:rPr>
+              <a:t>▸  Eigentum, Leitung und Haftung liegen in einer Hand – wer den Menschen nicht versteht, versteht das Kreditrisiko nicht.</a:t>
+            </a:r>
+          </a:p>
+        </p:txBody>
+      </p:sp>
+      <p:sp>
+        <p:nvSpPr>
+          <p:cNvPr id="9" name="Rectangle 8"/>
+          <p:cNvSpPr/>
+          <p:nvPr/>
+        </p:nvSpPr>
+        <p:spPr>
+          <a:xfrm>
+            <a:off x="0" y="6510528"/>
+            <a:ext cx="12188952" cy="347472"/>
+          </a:xfrm>
+          <a:prstGeom prst="rect">
+            <a:avLst/>
+          </a:prstGeom>
+          <a:solidFill>
+            <a:srgbClr val="0A1937"/>
+          </a:solidFill>
+          <a:ln>
+            <a:noFill/>
+          </a:ln>
+        </p:spPr>
+        <p:style>
+          <a:lnRef idx="1">
+            <a:schemeClr val="accent1"/>
+          </a:lnRef>
+          <a:fillRef idx="3">
+            <a:schemeClr val="accent1"/>
+          </a:fillRef>
+          <a:effectRef idx="2">
+            <a:schemeClr val="accent1"/>
+          </a:effectRef>
+          <a:fontRef idx="minor">
+            <a:schemeClr val="lt1"/>
+          </a:fontRef>
+        </p:style>
+        <p:txBody>
+          <a:bodyPr rtlCol="0" anchor="ctr"/>
+          <a:lstStyle/>
+          <a:p>
+            <a:pPr algn="ctr"/>
+          </a:p>
+        </p:txBody>
+      </p:sp>
+      <p:sp>
+        <p:nvSpPr>
+          <p:cNvPr id="10" name="TextBox 9"/>
+          <p:cNvSpPr txBox="1"/>
+          <p:nvPr/>
+        </p:nvSpPr>
+        <p:spPr>
+          <a:xfrm>
+            <a:off x="685800" y="6583680"/>
+            <a:ext cx="6490411" cy="256032"/>
+          </a:xfrm>
+          <a:prstGeom prst="rect">
+            <a:avLst/>
+          </a:prstGeom>
+          <a:noFill/>
+        </p:spPr>
+        <p:txBody>
+          <a:bodyPr wrap="none">
+            <a:spAutoFit/>
+          </a:bodyPr>
+          <a:lstStyle/>
+          <a:p>
+            <a:pPr algn="l"/>
+            <a:r>
+              <a:rPr sz="700">
+                <a:solidFill>
+                  <a:srgbClr val="A0B4D2"/>
+                </a:solidFill>
+                <a:latin typeface="Consolas"/>
+              </a:rPr>
+              <a:t>FKB Campus  ·  M06</a:t>
+            </a:r>
+          </a:p>
+        </p:txBody>
+      </p:sp>
+    </p:spTree>
+  </p:cSld>
+  <p:clrMapOvr>
+    <a:masterClrMapping/>
+  </p:clrMapOvr>
+</p:sld>
+</file>
+
+<file path=ppt/slides/slide16.xml><?xml version="1.0" encoding="utf-8"?>
+<p:sld xmlns:a="http://schemas.openxmlformats.org/drawingml/2006/main" xmlns:p="http://schemas.openxmlformats.org/presentationml/2006/main" xmlns:r="http://schemas.openxmlformats.org/officeDocument/2006/relationships">
+  <p:cSld>
+    <p:spTree>
+      <p:nvGrpSpPr>
+        <p:cNvPr id="1" name=""/>
+        <p:cNvGrpSpPr/>
+        <p:nvPr/>
+      </p:nvGrpSpPr>
+      <p:grpSpPr/>
+      <p:sp>
+        <p:nvSpPr>
+          <p:cNvPr id="2" name="Rectangle 1"/>
+          <p:cNvSpPr/>
+          <p:nvPr/>
+        </p:nvSpPr>
+        <p:spPr>
+          <a:xfrm>
+            <a:off x="0" y="0"/>
+            <a:ext cx="12188952" cy="6858000"/>
+          </a:xfrm>
+          <a:prstGeom prst="rect">
+            <a:avLst/>
+          </a:prstGeom>
+          <a:solidFill>
+            <a:srgbClr val="EDEDF3"/>
+          </a:solidFill>
+          <a:ln>
+            <a:noFill/>
+          </a:ln>
+        </p:spPr>
+        <p:style>
+          <a:lnRef idx="1">
+            <a:schemeClr val="accent1"/>
+          </a:lnRef>
+          <a:fillRef idx="3">
+            <a:schemeClr val="accent1"/>
+          </a:fillRef>
+          <a:effectRef idx="2">
+            <a:schemeClr val="accent1"/>
+          </a:effectRef>
+          <a:fontRef idx="minor">
+            <a:schemeClr val="lt1"/>
+          </a:fontRef>
+        </p:style>
+        <p:txBody>
+          <a:bodyPr rtlCol="0" anchor="ctr"/>
+          <a:lstStyle/>
+          <a:p>
+            <a:pPr algn="ctr"/>
+          </a:p>
+        </p:txBody>
+      </p:sp>
+      <p:sp>
+        <p:nvSpPr>
+          <p:cNvPr id="3" name="Rectangle 2"/>
+          <p:cNvSpPr/>
+          <p:nvPr/>
+        </p:nvSpPr>
+        <p:spPr>
+          <a:xfrm>
+            <a:off x="0" y="0"/>
+            <a:ext cx="12188952" cy="50292"/>
+          </a:xfrm>
+          <a:prstGeom prst="rect">
+            <a:avLst/>
+          </a:prstGeom>
+          <a:solidFill>
+            <a:srgbClr val="1F2C56"/>
+          </a:solidFill>
+          <a:ln>
+            <a:noFill/>
+          </a:ln>
+        </p:spPr>
+        <p:style>
+          <a:lnRef idx="1">
+            <a:schemeClr val="accent1"/>
+          </a:lnRef>
+          <a:fillRef idx="3">
+            <a:schemeClr val="accent1"/>
+          </a:fillRef>
+          <a:effectRef idx="2">
+            <a:schemeClr val="accent1"/>
+          </a:effectRef>
+          <a:fontRef idx="minor">
+            <a:schemeClr val="lt1"/>
+          </a:fontRef>
+        </p:style>
+        <p:txBody>
+          <a:bodyPr rtlCol="0" anchor="ctr"/>
+          <a:lstStyle/>
+          <a:p>
+            <a:pPr algn="ctr"/>
+          </a:p>
+        </p:txBody>
+      </p:sp>
+      <p:sp>
+        <p:nvSpPr>
+          <p:cNvPr id="4" name="TextBox 3"/>
+          <p:cNvSpPr txBox="1"/>
+          <p:nvPr/>
+        </p:nvSpPr>
+        <p:spPr>
+          <a:xfrm>
+            <a:off x="685800" y="109728"/>
+            <a:ext cx="10817352" cy="228600"/>
+          </a:xfrm>
+          <a:prstGeom prst="rect">
+            <a:avLst/>
+          </a:prstGeom>
+          <a:noFill/>
+        </p:spPr>
+        <p:txBody>
+          <a:bodyPr wrap="none">
+            <a:spAutoFit/>
+          </a:bodyPr>
+          <a:lstStyle/>
+          <a:p>
+            <a:pPr algn="l"/>
+            <a:r>
+              <a:rPr sz="750">
+                <a:solidFill>
+                  <a:srgbClr val="78808C"/>
+                </a:solidFill>
+                <a:latin typeface="Consolas"/>
+              </a:rPr>
+              <a:t>M06  ·  INHALT</a:t>
+            </a:r>
+          </a:p>
+        </p:txBody>
+      </p:sp>
+      <p:sp>
+        <p:nvSpPr>
+          <p:cNvPr id="5" name="Rectangle 4"/>
+          <p:cNvSpPr/>
+          <p:nvPr/>
+        </p:nvSpPr>
+        <p:spPr>
+          <a:xfrm>
+            <a:off x="0" y="1234440"/>
+            <a:ext cx="12188952" cy="12700"/>
+          </a:xfrm>
+          <a:prstGeom prst="rect">
+            <a:avLst/>
+          </a:prstGeom>
+          <a:solidFill>
+            <a:srgbClr val="D8DFE4"/>
+          </a:solidFill>
+          <a:ln>
+            <a:noFill/>
+          </a:ln>
+        </p:spPr>
+        <p:style>
+          <a:lnRef idx="1">
+            <a:schemeClr val="accent1"/>
+          </a:lnRef>
+          <a:fillRef idx="3">
+            <a:schemeClr val="accent1"/>
+          </a:fillRef>
+          <a:effectRef idx="2">
+            <a:schemeClr val="accent1"/>
+          </a:effectRef>
+          <a:fontRef idx="minor">
+            <a:schemeClr val="lt1"/>
+          </a:fontRef>
+        </p:style>
+        <p:txBody>
+          <a:bodyPr rtlCol="0" anchor="ctr"/>
+          <a:lstStyle/>
+          <a:p>
+            <a:pPr algn="ctr"/>
+          </a:p>
+        </p:txBody>
+      </p:sp>
+      <p:sp>
+        <p:nvSpPr>
+          <p:cNvPr id="6" name="Rectangle 5"/>
+          <p:cNvSpPr/>
+          <p:nvPr/>
+        </p:nvSpPr>
+        <p:spPr>
+          <a:xfrm>
+            <a:off x="685800" y="502920"/>
+            <a:ext cx="36576" cy="658368"/>
+          </a:xfrm>
+          <a:prstGeom prst="rect">
+            <a:avLst/>
+          </a:prstGeom>
+          <a:solidFill>
+            <a:srgbClr val="D9C089"/>
+          </a:solidFill>
+          <a:ln>
+            <a:noFill/>
+          </a:ln>
+        </p:spPr>
+        <p:style>
+          <a:lnRef idx="1">
+            <a:schemeClr val="accent1"/>
+          </a:lnRef>
+          <a:fillRef idx="3">
+            <a:schemeClr val="accent1"/>
+          </a:fillRef>
+          <a:effectRef idx="2">
+            <a:schemeClr val="accent1"/>
+          </a:effectRef>
+          <a:fontRef idx="minor">
+            <a:schemeClr val="lt1"/>
+          </a:fontRef>
+        </p:style>
+        <p:txBody>
+          <a:bodyPr rtlCol="0" anchor="ctr"/>
+          <a:lstStyle/>
+          <a:p>
+            <a:pPr algn="ctr"/>
+          </a:p>
+        </p:txBody>
+      </p:sp>
+      <p:sp>
+        <p:nvSpPr>
+          <p:cNvPr id="7" name="TextBox 6"/>
+          <p:cNvSpPr txBox="1"/>
+          <p:nvPr/>
+        </p:nvSpPr>
+        <p:spPr>
+          <a:xfrm>
+            <a:off x="813816" y="502920"/>
+            <a:ext cx="10634472" cy="685800"/>
+          </a:xfrm>
+          <a:prstGeom prst="rect">
+            <a:avLst/>
+          </a:prstGeom>
+          <a:noFill/>
+        </p:spPr>
+        <p:txBody>
+          <a:bodyPr wrap="square">
+            <a:spAutoFit/>
+          </a:bodyPr>
+          <a:lstStyle/>
+          <a:p>
+            <a:pPr algn="l"/>
+            <a:r>
+              <a:rPr sz="2400" b="1" i="0">
+                <a:solidFill>
+                  <a:srgbClr val="1F2C56"/>
+                </a:solidFill>
+                <a:latin typeface="Arial"/>
+              </a:rPr>
+              <a:t>Reflexion und Selbstcheck</a:t>
+            </a:r>
+          </a:p>
+        </p:txBody>
+      </p:sp>
+      <p:sp>
+        <p:nvSpPr>
+          <p:cNvPr id="8" name="TextBox 7"/>
+          <p:cNvSpPr txBox="1"/>
+          <p:nvPr/>
+        </p:nvSpPr>
+        <p:spPr>
+          <a:xfrm>
+            <a:off x="685800" y="1417320"/>
+            <a:ext cx="10817352" cy="4892040"/>
+          </a:xfrm>
+          <a:prstGeom prst="rect">
+            <a:avLst/>
+          </a:prstGeom>
+          <a:noFill/>
+        </p:spPr>
+        <p:txBody>
+          <a:bodyPr wrap="square" anchor="ctr">
+            <a:spAutoFit/>
+          </a:bodyPr>
+          <a:lstStyle/>
+          <a:p>
+            <a:pPr marL="190500" indent="-190500">
+              <a:spcBef>
+                <a:spcPts val="400"/>
+              </a:spcBef>
+              <a:spcAft>
+                <a:spcPts val="200"/>
+              </a:spcAft>
+            </a:pPr>
+            <a:r>
+              <a:rPr sz="1300">
+                <a:solidFill>
+                  <a:srgbClr val="3D5466"/>
+                </a:solidFill>
+                <a:latin typeface="Arial"/>
+              </a:rPr>
+              <a:t>▸  Bei welchem Ihrer KMU-Kunden hängt das Geschäft an einer einzigen Person?</a:t>
+            </a:r>
+          </a:p>
+          <a:p>
+            <a:pPr marL="190500" indent="-190500">
+              <a:spcBef>
+                <a:spcPts val="400"/>
+              </a:spcBef>
+              <a:spcAft>
+                <a:spcPts val="200"/>
+              </a:spcAft>
+            </a:pPr>
+            <a:r>
+              <a:rPr sz="1300">
+                <a:solidFill>
+                  <a:srgbClr val="3D5466"/>
+                </a:solidFill>
+                <a:latin typeface="Arial"/>
+              </a:rPr>
+              <a:t>▸  Welches strukturelle Risiko haben Sie zuletzt in der Bilanz gesucht, statt im Gespräch?</a:t>
+            </a:r>
+          </a:p>
+          <a:p>
+            <a:pPr marL="190500" indent="-190500">
+              <a:spcBef>
+                <a:spcPts val="400"/>
+              </a:spcBef>
+              <a:spcAft>
+                <a:spcPts val="200"/>
+              </a:spcAft>
+            </a:pPr>
+            <a:r>
+              <a:rPr sz="1300">
+                <a:solidFill>
+                  <a:srgbClr val="3D5466"/>
+                </a:solidFill>
+                <a:latin typeface="Arial"/>
+              </a:rPr>
+              <a:t>▸  Wie sprechen Sie eine Schlüsselpersonen-Absicherung an, ohne zu verkaufen?</a:t>
             </a:r>
           </a:p>
         </p:txBody>
@@ -8656,7 +9215,7 @@
                 </a:solidFill>
                 <a:latin typeface="Arial"/>
               </a:rPr>
-              <a:t>Theorie-Input 1: Was ist ein KMU? Definitionen, Typologien und volkswirtschaftliche Bedeutung</a:t>
+              <a:t>Unternehmen und Unternehmer sind nicht zu trennen</a:t>
             </a:r>
           </a:p>
         </p:txBody>
@@ -8678,27 +9237,27 @@
           <a:noFill/>
         </p:spPr>
         <p:txBody>
-          <a:bodyPr wrap="square">
+          <a:bodyPr wrap="square" anchor="ctr">
             <a:spAutoFit/>
           </a:bodyPr>
           <a:lstStyle/>
           <a:p>
-            <a:pPr>
+            <a:pPr marL="177800" indent="-177800">
               <a:spcBef>
-                <a:spcPts val="1000"/>
+                <a:spcPts val="600"/>
               </a:spcBef>
               <a:spcAft>
                 <a:spcPts val="200"/>
               </a:spcAft>
             </a:pPr>
             <a:r>
-              <a:rPr sz="800" b="1">
-                <a:solidFill>
-                  <a:srgbClr val="78808C"/>
-                </a:solidFill>
-                <a:latin typeface="Consolas"/>
+              <a:rPr sz="1200" i="1">
+                <a:solidFill>
+                  <a:srgbClr val="3D5466"/>
+                </a:solidFill>
+                <a:latin typeface="Arial"/>
               </a:rPr>
-              <a:t>DIE ZWEI ZENTRALEN KMU-DEFINITIONEN</a:t>
+              <a:t>→  Beim Mittelständler sind Unternehmen und Unternehmer nicht zu trennen – wer den Menschen nicht versteht, versteht das Kreditrisiko nicht.</a:t>
             </a:r>
           </a:p>
           <a:p>
@@ -8717,7 +9276,7 @@
                 </a:solidFill>
                 <a:latin typeface="Arial"/>
               </a:rPr>
-              <a:t>▸  In der deutschen Bankpraxis begegnen Berater zwei unterschiedlichen KMU-Definitionen, die für unterschiedliche Zwecke relevant sind.</a:t>
+              <a:t>▸  Eigentum, Leitung und Haftung liegen in einer Hand.</a:t>
             </a:r>
           </a:p>
           <a:p>
@@ -8736,178 +9295,7 @@
                 </a:solidFill>
                 <a:latin typeface="Arial"/>
               </a:rPr>
-              <a:t>▸  Die IfM-Bonn-Definition</a:t>
-            </a:r>
-          </a:p>
-          <a:p>
-            <a:pPr marL="190500" indent="-190500">
-              <a:spcBef>
-                <a:spcPts val="400"/>
-              </a:spcBef>
-              <a:spcAft>
-                <a:spcPts val="200"/>
-              </a:spcAft>
-            </a:pPr>
-            <a:r>
-              <a:rPr sz="1300">
-                <a:solidFill>
-                  <a:srgbClr val="3D5466"/>
-                </a:solidFill>
-                <a:latin typeface="Arial"/>
-              </a:rPr>
-              <a:t>▸  Das Institut für Mittelstandsforschung Bonn (IfM Bonn) definiert KMU quantitativ und qualitativ (IfM Bonn, 2024 ). Die Definition unterscheidet zwei Unternehmensgrößen:</a:t>
-            </a:r>
-          </a:p>
-          <a:p>
-            <a:pPr marL="190500" indent="-190500">
-              <a:spcBef>
-                <a:spcPts val="400"/>
-              </a:spcBef>
-              <a:spcAft>
-                <a:spcPts val="200"/>
-              </a:spcAft>
-            </a:pPr>
-            <a:r>
-              <a:rPr sz="1300">
-                <a:solidFill>
-                  <a:srgbClr val="3D5466"/>
-                </a:solidFill>
-                <a:latin typeface="Arial"/>
-              </a:rPr>
-              <a:t>▸  (Es müssen Mitarbeiterzahl UND Umsatz die Schwellenwerte erfüllen; IfM Bonn, 2024 )</a:t>
-            </a:r>
-          </a:p>
-          <a:p>
-            <a:pPr marL="190500" indent="-190500">
-              <a:spcBef>
-                <a:spcPts val="400"/>
-              </a:spcBef>
-              <a:spcAft>
-                <a:spcPts val="200"/>
-              </a:spcAft>
-            </a:pPr>
-            <a:r>
-              <a:rPr sz="1300">
-                <a:solidFill>
-                  <a:srgbClr val="3D5466"/>
-                </a:solidFill>
-                <a:latin typeface="Arial"/>
-              </a:rPr>
-              <a:t>▸  Die EU-Definition</a:t>
-            </a:r>
-          </a:p>
-          <a:p>
-            <a:pPr marL="190500" indent="-190500">
-              <a:spcBef>
-                <a:spcPts val="400"/>
-              </a:spcBef>
-              <a:spcAft>
-                <a:spcPts val="200"/>
-              </a:spcAft>
-            </a:pPr>
-            <a:r>
-              <a:rPr sz="1300">
-                <a:solidFill>
-                  <a:srgbClr val="3D5466"/>
-                </a:solidFill>
-                <a:latin typeface="Arial"/>
-              </a:rPr>
-              <a:t>▸  Die Europäische Kommission (2020 ) unterscheidet drei Unternehmensgrößen, die für EU-Förderprogramme und KfW-Finanzierungsprodukte unmittelbar relevant sind:</a:t>
-            </a:r>
-          </a:p>
-          <a:p>
-            <a:pPr marL="190500" indent="-190500">
-              <a:spcBef>
-                <a:spcPts val="400"/>
-              </a:spcBef>
-              <a:spcAft>
-                <a:spcPts val="200"/>
-              </a:spcAft>
-            </a:pPr>
-            <a:r>
-              <a:rPr sz="1300">
-                <a:solidFill>
-                  <a:srgbClr val="3D5466"/>
-                </a:solidFill>
-                <a:latin typeface="Arial"/>
-              </a:rPr>
-              <a:t>▸  Es müssen Mitarbeiterzahl UND (Umsatz ODER Bilanzsumme) die jeweiligen Schwellenwerte erfüllen (Europäische Kommission, 2020 ).</a:t>
-            </a:r>
-          </a:p>
-          <a:p>
-            <a:pPr marL="190500" indent="-190500">
-              <a:spcBef>
-                <a:spcPts val="400"/>
-              </a:spcBef>
-              <a:spcAft>
-                <a:spcPts val="200"/>
-              </a:spcAft>
-            </a:pPr>
-            <a:r>
-              <a:rPr sz="1300">
-                <a:solidFill>
-                  <a:srgbClr val="3D5466"/>
-                </a:solidFill>
-                <a:latin typeface="Arial"/>
-              </a:rPr>
-              <a:t>▸  Praktische Relevanz der Unterscheidung</a:t>
-            </a:r>
-          </a:p>
-          <a:p>
-            <a:pPr marL="177800" indent="-177800">
-              <a:spcBef>
-                <a:spcPts val="600"/>
-              </a:spcBef>
-              <a:spcAft>
-                <a:spcPts val="200"/>
-              </a:spcAft>
-            </a:pPr>
-            <a:r>
-              <a:rPr sz="1200" i="1">
-                <a:solidFill>
-                  <a:srgbClr val="3D5466"/>
-                </a:solidFill>
-                <a:latin typeface="Arial"/>
-              </a:rPr>
-              <a:t>→  Praxishinweis: Unternehmensgruppen und verbundene Unternehmen</a:t>
-            </a:r>
-          </a:p>
-          <a:p>
-            <a:pPr>
-              <a:spcBef>
-                <a:spcPts val="1000"/>
-              </a:spcBef>
-              <a:spcAft>
-                <a:spcPts val="200"/>
-              </a:spcAft>
-            </a:pPr>
-            <a:r>
-              <a:rPr sz="800" b="1">
-                <a:solidFill>
-                  <a:srgbClr val="78808C"/>
-                </a:solidFill>
-                <a:latin typeface="Consolas"/>
-              </a:rPr>
-              <a:t>VOLKSWIRTSCHAFTLICHE BEDEUTUNG VON KMU</a:t>
-            </a:r>
-          </a:p>
-          <a:p>
-            <a:pPr marL="190500" indent="-190500">
-              <a:spcBef>
-                <a:spcPts val="400"/>
-              </a:spcBef>
-              <a:spcAft>
-                <a:spcPts val="200"/>
-              </a:spcAft>
-            </a:pPr>
-            <a:r>
-              <a:rPr sz="1300">
-                <a:solidFill>
-                  <a:srgbClr val="3D5466"/>
-                </a:solidFill>
-                <a:latin typeface="Arial"/>
-              </a:rPr>
-              <a:t>▸  KMU sind kein Randphänomen, sondern das Fundament der deutschen Wirtschaftsstruktur:</a:t>
+              <a:t>▸  Die Person des Inhabers ist zugleich größtes Asset und größtes Risiko.</a:t>
             </a:r>
           </a:p>
         </p:txBody>
@@ -9023,7 +9411,7 @@
             <a:avLst/>
           </a:prstGeom>
           <a:solidFill>
-            <a:srgbClr val="FFFFFF"/>
+            <a:srgbClr val="EDEDF3"/>
           </a:solidFill>
           <a:ln>
             <a:noFill/>
@@ -9124,43 +9512,51 @@
                 </a:solidFill>
                 <a:latin typeface="Consolas"/>
               </a:rPr>
-              <a:t>M06  ·  SCHAUBILD</a:t>
-            </a:r>
-          </a:p>
-        </p:txBody>
-      </p:sp>
-      <p:sp>
-        <p:nvSpPr>
-          <p:cNvPr id="5" name="TextBox 4"/>
-          <p:cNvSpPr txBox="1"/>
-          <p:nvPr/>
-        </p:nvSpPr>
-        <p:spPr>
-          <a:xfrm>
-            <a:off x="685800" y="502920"/>
-            <a:ext cx="10817352" cy="594360"/>
-          </a:xfrm>
-          <a:prstGeom prst="rect">
-            <a:avLst/>
-          </a:prstGeom>
-          <a:noFill/>
-        </p:spPr>
-        <p:txBody>
-          <a:bodyPr wrap="square">
-            <a:spAutoFit/>
-          </a:bodyPr>
-          <a:lstStyle/>
-          <a:p>
-            <a:pPr algn="l"/>
-            <a:r>
-              <a:rPr sz="2000" b="1" i="0">
-                <a:solidFill>
-                  <a:srgbClr val="1F2C56"/>
-                </a:solidFill>
-                <a:latin typeface="Arial"/>
-              </a:rPr>
-              <a:t>Zwei KMU-Definitionen im Vergleich</a:t>
-            </a:r>
+              <a:t>M06  ·  INHALT</a:t>
+            </a:r>
+          </a:p>
+        </p:txBody>
+      </p:sp>
+      <p:sp>
+        <p:nvSpPr>
+          <p:cNvPr id="5" name="Rectangle 4"/>
+          <p:cNvSpPr/>
+          <p:nvPr/>
+        </p:nvSpPr>
+        <p:spPr>
+          <a:xfrm>
+            <a:off x="0" y="1234440"/>
+            <a:ext cx="12188952" cy="12700"/>
+          </a:xfrm>
+          <a:prstGeom prst="rect">
+            <a:avLst/>
+          </a:prstGeom>
+          <a:solidFill>
+            <a:srgbClr val="D8DFE4"/>
+          </a:solidFill>
+          <a:ln>
+            <a:noFill/>
+          </a:ln>
+        </p:spPr>
+        <p:style>
+          <a:lnRef idx="1">
+            <a:schemeClr val="accent1"/>
+          </a:lnRef>
+          <a:fillRef idx="3">
+            <a:schemeClr val="accent1"/>
+          </a:fillRef>
+          <a:effectRef idx="2">
+            <a:schemeClr val="accent1"/>
+          </a:effectRef>
+          <a:fontRef idx="minor">
+            <a:schemeClr val="lt1"/>
+          </a:fontRef>
+        </p:style>
+        <p:txBody>
+          <a:bodyPr rtlCol="0" anchor="ctr"/>
+          <a:lstStyle/>
+          <a:p>
+            <a:pPr algn="ctr"/>
           </a:p>
         </p:txBody>
       </p:sp>
@@ -9172,8 +9568,8 @@
         </p:nvSpPr>
         <p:spPr>
           <a:xfrm>
-            <a:off x="685800" y="1143000"/>
-            <a:ext cx="10817352" cy="25400"/>
+            <a:off x="685800" y="502920"/>
+            <a:ext cx="36576" cy="658368"/>
           </a:xfrm>
           <a:prstGeom prst="rect">
             <a:avLst/>
@@ -9207,33 +9603,124 @@
           </a:p>
         </p:txBody>
       </p:sp>
-      <p:pic>
-        <p:nvPicPr>
-          <p:cNvPr id="7" name="Picture 6" descr="image.png"/>
-          <p:cNvPicPr>
-            <a:picLocks noChangeAspect="1"/>
-          </p:cNvPicPr>
-          <p:nvPr/>
-        </p:nvPicPr>
-        <p:blipFill>
-          <a:blip r:embed="rId2"/>
-          <a:stretch>
-            <a:fillRect/>
-          </a:stretch>
-        </p:blipFill>
-        <p:spPr>
-          <a:xfrm>
-            <a:off x="2303489" y="1325880"/>
-            <a:ext cx="7581973" cy="4937760"/>
-          </a:xfrm>
-          <a:prstGeom prst="rect">
-            <a:avLst/>
-          </a:prstGeom>
-        </p:spPr>
-      </p:pic>
-      <p:sp>
-        <p:nvSpPr>
-          <p:cNvPr id="8" name="Rectangle 7"/>
+      <p:sp>
+        <p:nvSpPr>
+          <p:cNvPr id="7" name="TextBox 6"/>
+          <p:cNvSpPr txBox="1"/>
+          <p:nvPr/>
+        </p:nvSpPr>
+        <p:spPr>
+          <a:xfrm>
+            <a:off x="813816" y="502920"/>
+            <a:ext cx="10634472" cy="685800"/>
+          </a:xfrm>
+          <a:prstGeom prst="rect">
+            <a:avLst/>
+          </a:prstGeom>
+          <a:noFill/>
+        </p:spPr>
+        <p:txBody>
+          <a:bodyPr wrap="square">
+            <a:spAutoFit/>
+          </a:bodyPr>
+          <a:lstStyle/>
+          <a:p>
+            <a:pPr algn="l"/>
+            <a:r>
+              <a:rPr sz="2400" b="1" i="0">
+                <a:solidFill>
+                  <a:srgbClr val="1F2C56"/>
+                </a:solidFill>
+                <a:latin typeface="Arial"/>
+              </a:rPr>
+              <a:t>Was ist ein KMU? Zwei Definitionen</a:t>
+            </a:r>
+          </a:p>
+        </p:txBody>
+      </p:sp>
+      <p:sp>
+        <p:nvSpPr>
+          <p:cNvPr id="8" name="TextBox 7"/>
+          <p:cNvSpPr txBox="1"/>
+          <p:nvPr/>
+        </p:nvSpPr>
+        <p:spPr>
+          <a:xfrm>
+            <a:off x="685800" y="1417320"/>
+            <a:ext cx="10817352" cy="4892040"/>
+          </a:xfrm>
+          <a:prstGeom prst="rect">
+            <a:avLst/>
+          </a:prstGeom>
+          <a:noFill/>
+        </p:spPr>
+        <p:txBody>
+          <a:bodyPr wrap="square" anchor="ctr">
+            <a:spAutoFit/>
+          </a:bodyPr>
+          <a:lstStyle/>
+          <a:p>
+            <a:pPr marL="177800" indent="-177800">
+              <a:spcBef>
+                <a:spcPts val="600"/>
+              </a:spcBef>
+              <a:spcAft>
+                <a:spcPts val="200"/>
+              </a:spcAft>
+            </a:pPr>
+            <a:r>
+              <a:rPr sz="1200" i="1">
+                <a:solidFill>
+                  <a:srgbClr val="3D5466"/>
+                </a:solidFill>
+                <a:latin typeface="Arial"/>
+              </a:rPr>
+              <a:t>→  KMU ist nicht gleich KMU – die EU-Definition und die HGB-Größenklassen fassen unterschiedlich ab.</a:t>
+            </a:r>
+          </a:p>
+          <a:p>
+            <a:pPr marL="190500" indent="-190500">
+              <a:spcBef>
+                <a:spcPts val="400"/>
+              </a:spcBef>
+              <a:spcAft>
+                <a:spcPts val="200"/>
+              </a:spcAft>
+            </a:pPr>
+            <a:r>
+              <a:rPr sz="1300">
+                <a:solidFill>
+                  <a:srgbClr val="3D5466"/>
+                </a:solidFill>
+                <a:latin typeface="Arial"/>
+              </a:rPr>
+              <a:t>▸  EU-Empfehlung: Mitarbeiter, Umsatz, Bilanzsumme.</a:t>
+            </a:r>
+          </a:p>
+          <a:p>
+            <a:pPr marL="190500" indent="-190500">
+              <a:spcBef>
+                <a:spcPts val="400"/>
+              </a:spcBef>
+              <a:spcAft>
+                <a:spcPts val="200"/>
+              </a:spcAft>
+            </a:pPr>
+            <a:r>
+              <a:rPr sz="1300">
+                <a:solidFill>
+                  <a:srgbClr val="3D5466"/>
+                </a:solidFill>
+                <a:latin typeface="Arial"/>
+              </a:rPr>
+              <a:t>▸  HGB § 267: Größenklassen mit Rechtsfolgen für Offenlegung und Prüfung.</a:t>
+            </a:r>
+          </a:p>
+        </p:txBody>
+      </p:sp>
+      <p:sp>
+        <p:nvSpPr>
+          <p:cNvPr id="9" name="Rectangle 8"/>
           <p:cNvSpPr/>
           <p:nvPr/>
         </p:nvSpPr>
@@ -9276,7 +9763,7 @@
       </p:sp>
       <p:sp>
         <p:nvSpPr>
-          <p:cNvPr id="9" name="TextBox 8"/>
+          <p:cNvPr id="10" name="TextBox 9"/>
           <p:cNvSpPr txBox="1"/>
           <p:nvPr/>
         </p:nvSpPr>
@@ -9305,41 +9792,6 @@
                 <a:latin typeface="Consolas"/>
               </a:rPr>
               <a:t>FKB Campus  ·  M06</a:t>
-            </a:r>
-          </a:p>
-        </p:txBody>
-      </p:sp>
-      <p:sp>
-        <p:nvSpPr>
-          <p:cNvPr id="10" name="TextBox 9"/>
-          <p:cNvSpPr txBox="1"/>
-          <p:nvPr/>
-        </p:nvSpPr>
-        <p:spPr>
-          <a:xfrm>
-            <a:off x="7176211" y="6583680"/>
-            <a:ext cx="4326940" cy="256032"/>
-          </a:xfrm>
-          <a:prstGeom prst="rect">
-            <a:avLst/>
-          </a:prstGeom>
-          <a:noFill/>
-        </p:spPr>
-        <p:txBody>
-          <a:bodyPr wrap="none">
-            <a:spAutoFit/>
-          </a:bodyPr>
-          <a:lstStyle/>
-          <a:p>
-            <a:pPr algn="r"/>
-            <a:r>
-              <a:rPr sz="700">
-                <a:solidFill>
-                  <a:srgbClr val="A0B4D2"/>
-                </a:solidFill>
-                <a:latin typeface="Consolas"/>
-              </a:rPr>
-              <a:t>Schaubild</a:t>
             </a:r>
           </a:p>
         </p:txBody>
@@ -9478,7 +9930,7 @@
                 </a:solidFill>
                 <a:latin typeface="Consolas"/>
               </a:rPr>
-              <a:t>M06  ·  ÜBERSICHT</a:t>
+              <a:t>M06  ·  SCHAUBILD</a:t>
             </a:r>
           </a:p>
         </p:txBody>
@@ -9513,7 +9965,7 @@
                 </a:solidFill>
                 <a:latin typeface="Arial"/>
               </a:rPr>
-              <a:t>Theorie-Input 1: Was ist ein KMU? Definitionen, Typologien und volkswirtschaftliche Bedeutung</a:t>
+              <a:t>Zwei KMU-Definitionen im Vergleich</a:t>
             </a:r>
           </a:p>
         </p:txBody>
@@ -9561,269 +10013,30 @@
           </a:p>
         </p:txBody>
       </p:sp>
-      <p:graphicFrame>
-        <p:nvGraphicFramePr>
-          <p:cNvPr id="7" name="Table 6"/>
-          <p:cNvGraphicFramePr>
-            <a:graphicFrameLocks noGrp="1"/>
-          </p:cNvGraphicFramePr>
-          <p:nvPr/>
-        </p:nvGraphicFramePr>
-        <p:xfrm>
-          <a:off x="685800" y="1417320"/>
-          <a:ext cx="10817352" cy="1536192"/>
-        </p:xfrm>
-        <a:graphic>
-          <a:graphicData uri="http://schemas.openxmlformats.org/drawingml/2006/table">
-            <a:tbl>
-              <a:tblPr firstRow="1" bandRow="1">
-                <a:tableStyleId>{5C22544A-7EE6-4342-B048-85BDC9FD1C3A}</a:tableStyleId>
-              </a:tblPr>
-              <a:tblGrid>
-                <a:gridCol w="3605784"/>
-                <a:gridCol w="3605784"/>
-                <a:gridCol w="3605784"/>
-              </a:tblGrid>
-              <a:tr h="384048">
-                <a:tc>
-                  <a:txBody>
-                    <a:bodyPr/>
-                    <a:lstStyle/>
-                    <a:p>
-                      <a:r>
-                        <a:rPr sz="1100" b="1">
-                          <a:solidFill>
-                            <a:srgbClr val="FFFFFF"/>
-                          </a:solidFill>
-                          <a:latin typeface="Arial"/>
-                        </a:rPr>
-                        <a:t>Kategorie</a:t>
-                      </a:r>
-                    </a:p>
-                  </a:txBody>
-                  <a:tcPr>
-                    <a:solidFill>
-                      <a:srgbClr val="1F2C56"/>
-                    </a:solidFill>
-                  </a:tcPr>
-                </a:tc>
-                <a:tc>
-                  <a:txBody>
-                    <a:bodyPr/>
-                    <a:lstStyle/>
-                    <a:p>
-                      <a:r>
-                        <a:rPr sz="1100" b="1">
-                          <a:solidFill>
-                            <a:srgbClr val="FFFFFF"/>
-                          </a:solidFill>
-                          <a:latin typeface="Arial"/>
-                        </a:rPr>
-                        <a:t>Beschäftigte</a:t>
-                      </a:r>
-                    </a:p>
-                  </a:txBody>
-                  <a:tcPr>
-                    <a:solidFill>
-                      <a:srgbClr val="1F2C56"/>
-                    </a:solidFill>
-                  </a:tcPr>
-                </a:tc>
-                <a:tc>
-                  <a:txBody>
-                    <a:bodyPr/>
-                    <a:lstStyle/>
-                    <a:p>
-                      <a:r>
-                        <a:rPr sz="1100" b="1">
-                          <a:solidFill>
-                            <a:srgbClr val="FFFFFF"/>
-                          </a:solidFill>
-                          <a:latin typeface="Arial"/>
-                        </a:rPr>
-                        <a:t>Jahresumsatz</a:t>
-                      </a:r>
-                    </a:p>
-                  </a:txBody>
-                  <a:tcPr>
-                    <a:solidFill>
-                      <a:srgbClr val="1F2C56"/>
-                    </a:solidFill>
-                  </a:tcPr>
-                </a:tc>
-              </a:tr>
-              <a:tr h="384048">
-                <a:tc>
-                  <a:txBody>
-                    <a:bodyPr/>
-                    <a:lstStyle/>
-                    <a:p>
-                      <a:r>
-                        <a:rPr sz="1050">
-                          <a:solidFill>
-                            <a:srgbClr val="3D5466"/>
-                          </a:solidFill>
-                          <a:latin typeface="Arial"/>
-                        </a:rPr>
-                        <a:t>Kleine Unternehmen</a:t>
-                      </a:r>
-                    </a:p>
-                  </a:txBody>
-                  <a:tcPr/>
-                </a:tc>
-                <a:tc>
-                  <a:txBody>
-                    <a:bodyPr/>
-                    <a:lstStyle/>
-                    <a:p>
-                      <a:r>
-                        <a:rPr sz="1050">
-                          <a:solidFill>
-                            <a:srgbClr val="3D5466"/>
-                          </a:solidFill>
-                          <a:latin typeface="Arial"/>
-                        </a:rPr>
-                        <a:t>&lt; 10</a:t>
-                      </a:r>
-                    </a:p>
-                  </a:txBody>
-                  <a:tcPr/>
-                </a:tc>
-                <a:tc>
-                  <a:txBody>
-                    <a:bodyPr/>
-                    <a:lstStyle/>
-                    <a:p>
-                      <a:r>
-                        <a:rPr sz="1050">
-                          <a:solidFill>
-                            <a:srgbClr val="3D5466"/>
-                          </a:solidFill>
-                          <a:latin typeface="Arial"/>
-                        </a:rPr>
-                        <a:t>&lt; 2 Mio. EUR</a:t>
-                      </a:r>
-                    </a:p>
-                  </a:txBody>
-                  <a:tcPr/>
-                </a:tc>
-              </a:tr>
-              <a:tr h="384048">
-                <a:tc>
-                  <a:txBody>
-                    <a:bodyPr/>
-                    <a:lstStyle/>
-                    <a:p>
-                      <a:r>
-                        <a:rPr sz="1050">
-                          <a:solidFill>
-                            <a:srgbClr val="3D5466"/>
-                          </a:solidFill>
-                          <a:latin typeface="Arial"/>
-                        </a:rPr>
-                        <a:t>Mittlere Unternehmen</a:t>
-                      </a:r>
-                    </a:p>
-                  </a:txBody>
-                  <a:tcPr/>
-                </a:tc>
-                <a:tc>
-                  <a:txBody>
-                    <a:bodyPr/>
-                    <a:lstStyle/>
-                    <a:p>
-                      <a:r>
-                        <a:rPr sz="1050">
-                          <a:solidFill>
-                            <a:srgbClr val="3D5466"/>
-                          </a:solidFill>
-                          <a:latin typeface="Arial"/>
-                        </a:rPr>
-                        <a:t>10–499</a:t>
-                      </a:r>
-                    </a:p>
-                  </a:txBody>
-                  <a:tcPr/>
-                </a:tc>
-                <a:tc>
-                  <a:txBody>
-                    <a:bodyPr/>
-                    <a:lstStyle/>
-                    <a:p>
-                      <a:r>
-                        <a:rPr sz="1050">
-                          <a:solidFill>
-                            <a:srgbClr val="3D5466"/>
-                          </a:solidFill>
-                          <a:latin typeface="Arial"/>
-                        </a:rPr>
-                        <a:t>2–49,9 Mio. EUR</a:t>
-                      </a:r>
-                    </a:p>
-                  </a:txBody>
-                  <a:tcPr/>
-                </a:tc>
-              </a:tr>
-              <a:tr h="384048">
-                <a:tc>
-                  <a:txBody>
-                    <a:bodyPr/>
-                    <a:lstStyle/>
-                    <a:p>
-                      <a:r>
-                        <a:rPr sz="1050">
-                          <a:solidFill>
-                            <a:srgbClr val="3D5466"/>
-                          </a:solidFill>
-                          <a:latin typeface="Arial"/>
-                        </a:rPr>
-                        <a:t>KMU gesamt</a:t>
-                      </a:r>
-                    </a:p>
-                  </a:txBody>
-                  <a:tcPr/>
-                </a:tc>
-                <a:tc>
-                  <a:txBody>
-                    <a:bodyPr/>
-                    <a:lstStyle/>
-                    <a:p>
-                      <a:r>
-                        <a:rPr sz="1050">
-                          <a:solidFill>
-                            <a:srgbClr val="3D5466"/>
-                          </a:solidFill>
-                          <a:latin typeface="Arial"/>
-                        </a:rPr>
-                        <a:t>&lt; 500</a:t>
-                      </a:r>
-                    </a:p>
-                  </a:txBody>
-                  <a:tcPr/>
-                </a:tc>
-                <a:tc>
-                  <a:txBody>
-                    <a:bodyPr/>
-                    <a:lstStyle/>
-                    <a:p>
-                      <a:r>
-                        <a:rPr sz="1050">
-                          <a:solidFill>
-                            <a:srgbClr val="3D5466"/>
-                          </a:solidFill>
-                          <a:latin typeface="Arial"/>
-                        </a:rPr>
-                        <a:t>&lt; 50 Mio. EUR</a:t>
-                      </a:r>
-                    </a:p>
-                  </a:txBody>
-                  <a:tcPr/>
-                </a:tc>
-              </a:tr>
-            </a:tbl>
-          </a:graphicData>
-        </a:graphic>
-      </p:graphicFrame>
+      <p:pic>
+        <p:nvPicPr>
+          <p:cNvPr id="7" name="Picture 6" descr="image.png"/>
+          <p:cNvPicPr>
+            <a:picLocks noChangeAspect="1"/>
+          </p:cNvPicPr>
+          <p:nvPr/>
+        </p:nvPicPr>
+        <p:blipFill>
+          <a:blip r:embed="rId2"/>
+          <a:stretch>
+            <a:fillRect/>
+          </a:stretch>
+        </p:blipFill>
+        <p:spPr>
+          <a:xfrm>
+            <a:off x="2303489" y="1325880"/>
+            <a:ext cx="7581973" cy="4937760"/>
+          </a:xfrm>
+          <a:prstGeom prst="rect">
+            <a:avLst/>
+          </a:prstGeom>
+        </p:spPr>
+      </p:pic>
       <p:sp>
         <p:nvSpPr>
           <p:cNvPr id="8" name="Rectangle 7"/>
@@ -9932,7 +10145,7 @@
                 </a:solidFill>
                 <a:latin typeface="Consolas"/>
               </a:rPr>
-              <a:t>Übersicht</a:t>
+              <a:t>Schaubild</a:t>
             </a:r>
           </a:p>
         </p:txBody>
@@ -9970,7 +10183,7 @@
             <a:avLst/>
           </a:prstGeom>
           <a:solidFill>
-            <a:srgbClr val="FFFFFF"/>
+            <a:srgbClr val="EDEDF3"/>
           </a:solidFill>
           <a:ln>
             <a:noFill/>
@@ -10071,43 +10284,51 @@
                 </a:solidFill>
                 <a:latin typeface="Consolas"/>
               </a:rPr>
-              <a:t>M06  ·  ÜBERSICHT</a:t>
-            </a:r>
-          </a:p>
-        </p:txBody>
-      </p:sp>
-      <p:sp>
-        <p:nvSpPr>
-          <p:cNvPr id="5" name="TextBox 4"/>
-          <p:cNvSpPr txBox="1"/>
-          <p:nvPr/>
-        </p:nvSpPr>
-        <p:spPr>
-          <a:xfrm>
-            <a:off x="685800" y="502920"/>
-            <a:ext cx="10817352" cy="594360"/>
-          </a:xfrm>
-          <a:prstGeom prst="rect">
-            <a:avLst/>
-          </a:prstGeom>
-          <a:noFill/>
-        </p:spPr>
-        <p:txBody>
-          <a:bodyPr wrap="square">
-            <a:spAutoFit/>
-          </a:bodyPr>
-          <a:lstStyle/>
-          <a:p>
-            <a:pPr algn="l"/>
-            <a:r>
-              <a:rPr sz="2000" b="1" i="0">
-                <a:solidFill>
-                  <a:srgbClr val="1F2C56"/>
-                </a:solidFill>
-                <a:latin typeface="Arial"/>
-              </a:rPr>
-              <a:t>Theorie-Input 1: Was ist ein KMU? Definitionen, Typologien und volkswirtschaftliche Bedeutung</a:t>
-            </a:r>
+              <a:t>M06  ·  INHALT</a:t>
+            </a:r>
+          </a:p>
+        </p:txBody>
+      </p:sp>
+      <p:sp>
+        <p:nvSpPr>
+          <p:cNvPr id="5" name="Rectangle 4"/>
+          <p:cNvSpPr/>
+          <p:nvPr/>
+        </p:nvSpPr>
+        <p:spPr>
+          <a:xfrm>
+            <a:off x="0" y="1234440"/>
+            <a:ext cx="12188952" cy="12700"/>
+          </a:xfrm>
+          <a:prstGeom prst="rect">
+            <a:avLst/>
+          </a:prstGeom>
+          <a:solidFill>
+            <a:srgbClr val="D8DFE4"/>
+          </a:solidFill>
+          <a:ln>
+            <a:noFill/>
+          </a:ln>
+        </p:spPr>
+        <p:style>
+          <a:lnRef idx="1">
+            <a:schemeClr val="accent1"/>
+          </a:lnRef>
+          <a:fillRef idx="3">
+            <a:schemeClr val="accent1"/>
+          </a:fillRef>
+          <a:effectRef idx="2">
+            <a:schemeClr val="accent1"/>
+          </a:effectRef>
+          <a:fontRef idx="minor">
+            <a:schemeClr val="lt1"/>
+          </a:fontRef>
+        </p:style>
+        <p:txBody>
+          <a:bodyPr rtlCol="0" anchor="ctr"/>
+          <a:lstStyle/>
+          <a:p>
+            <a:pPr algn="ctr"/>
           </a:p>
         </p:txBody>
       </p:sp>
@@ -10119,8 +10340,8 @@
         </p:nvSpPr>
         <p:spPr>
           <a:xfrm>
-            <a:off x="685800" y="1143000"/>
-            <a:ext cx="10817352" cy="25400"/>
+            <a:off x="685800" y="502920"/>
+            <a:ext cx="36576" cy="658368"/>
           </a:xfrm>
           <a:prstGeom prst="rect">
             <a:avLst/>
@@ -10154,349 +10375,143 @@
           </a:p>
         </p:txBody>
       </p:sp>
-      <p:graphicFrame>
-        <p:nvGraphicFramePr>
-          <p:cNvPr id="7" name="Table 6"/>
-          <p:cNvGraphicFramePr>
-            <a:graphicFrameLocks noGrp="1"/>
-          </p:cNvGraphicFramePr>
-          <p:nvPr/>
-        </p:nvGraphicFramePr>
-        <p:xfrm>
-          <a:off x="685800" y="1417320"/>
-          <a:ext cx="10817352" cy="1536192"/>
-        </p:xfrm>
-        <a:graphic>
-          <a:graphicData uri="http://schemas.openxmlformats.org/drawingml/2006/table">
-            <a:tbl>
-              <a:tblPr firstRow="1" bandRow="1">
-                <a:tableStyleId>{5C22544A-7EE6-4342-B048-85BDC9FD1C3A}</a:tableStyleId>
-              </a:tblPr>
-              <a:tblGrid>
-                <a:gridCol w="2704338"/>
-                <a:gridCol w="2704338"/>
-                <a:gridCol w="2704338"/>
-                <a:gridCol w="2704338"/>
-              </a:tblGrid>
-              <a:tr h="384048">
-                <a:tc>
-                  <a:txBody>
-                    <a:bodyPr/>
-                    <a:lstStyle/>
-                    <a:p>
-                      <a:r>
-                        <a:rPr sz="1100" b="1">
-                          <a:solidFill>
-                            <a:srgbClr val="FFFFFF"/>
-                          </a:solidFill>
-                          <a:latin typeface="Arial"/>
-                        </a:rPr>
-                        <a:t>Kategorie</a:t>
-                      </a:r>
-                    </a:p>
-                  </a:txBody>
-                  <a:tcPr>
-                    <a:solidFill>
-                      <a:srgbClr val="1F2C56"/>
-                    </a:solidFill>
-                  </a:tcPr>
-                </a:tc>
-                <a:tc>
-                  <a:txBody>
-                    <a:bodyPr/>
-                    <a:lstStyle/>
-                    <a:p>
-                      <a:r>
-                        <a:rPr sz="1100" b="1">
-                          <a:solidFill>
-                            <a:srgbClr val="FFFFFF"/>
-                          </a:solidFill>
-                          <a:latin typeface="Arial"/>
-                        </a:rPr>
-                        <a:t>Beschäftigte</a:t>
-                      </a:r>
-                    </a:p>
-                  </a:txBody>
-                  <a:tcPr>
-                    <a:solidFill>
-                      <a:srgbClr val="1F2C56"/>
-                    </a:solidFill>
-                  </a:tcPr>
-                </a:tc>
-                <a:tc>
-                  <a:txBody>
-                    <a:bodyPr/>
-                    <a:lstStyle/>
-                    <a:p>
-                      <a:r>
-                        <a:rPr sz="1100" b="1">
-                          <a:solidFill>
-                            <a:srgbClr val="FFFFFF"/>
-                          </a:solidFill>
-                          <a:latin typeface="Arial"/>
-                        </a:rPr>
-                        <a:t>Jahresumsatz</a:t>
-                      </a:r>
-                    </a:p>
-                  </a:txBody>
-                  <a:tcPr>
-                    <a:solidFill>
-                      <a:srgbClr val="1F2C56"/>
-                    </a:solidFill>
-                  </a:tcPr>
-                </a:tc>
-                <a:tc>
-                  <a:txBody>
-                    <a:bodyPr/>
-                    <a:lstStyle/>
-                    <a:p>
-                      <a:r>
-                        <a:rPr sz="1100" b="1">
-                          <a:solidFill>
-                            <a:srgbClr val="FFFFFF"/>
-                          </a:solidFill>
-                          <a:latin typeface="Arial"/>
-                        </a:rPr>
-                        <a:t>Bilanzsumme</a:t>
-                      </a:r>
-                    </a:p>
-                  </a:txBody>
-                  <a:tcPr>
-                    <a:solidFill>
-                      <a:srgbClr val="1F2C56"/>
-                    </a:solidFill>
-                  </a:tcPr>
-                </a:tc>
-              </a:tr>
-              <a:tr h="384048">
-                <a:tc>
-                  <a:txBody>
-                    <a:bodyPr/>
-                    <a:lstStyle/>
-                    <a:p>
-                      <a:r>
-                        <a:rPr sz="1050">
-                          <a:solidFill>
-                            <a:srgbClr val="3D5466"/>
-                          </a:solidFill>
-                          <a:latin typeface="Arial"/>
-                        </a:rPr>
-                        <a:t>Kleinstunternehmen</a:t>
-                      </a:r>
-                    </a:p>
-                  </a:txBody>
-                  <a:tcPr/>
-                </a:tc>
-                <a:tc>
-                  <a:txBody>
-                    <a:bodyPr/>
-                    <a:lstStyle/>
-                    <a:p>
-                      <a:r>
-                        <a:rPr sz="1050">
-                          <a:solidFill>
-                            <a:srgbClr val="3D5466"/>
-                          </a:solidFill>
-                          <a:latin typeface="Arial"/>
-                        </a:rPr>
-                        <a:t>&lt; 10</a:t>
-                      </a:r>
-                    </a:p>
-                  </a:txBody>
-                  <a:tcPr/>
-                </a:tc>
-                <a:tc>
-                  <a:txBody>
-                    <a:bodyPr/>
-                    <a:lstStyle/>
-                    <a:p>
-                      <a:r>
-                        <a:rPr sz="1050">
-                          <a:solidFill>
-                            <a:srgbClr val="3D5466"/>
-                          </a:solidFill>
-                          <a:latin typeface="Arial"/>
-                        </a:rPr>
-                        <a:t>≤ 2 Mio. EUR</a:t>
-                      </a:r>
-                    </a:p>
-                  </a:txBody>
-                  <a:tcPr/>
-                </a:tc>
-                <a:tc>
-                  <a:txBody>
-                    <a:bodyPr/>
-                    <a:lstStyle/>
-                    <a:p>
-                      <a:r>
-                        <a:rPr sz="1050">
-                          <a:solidFill>
-                            <a:srgbClr val="3D5466"/>
-                          </a:solidFill>
-                          <a:latin typeface="Arial"/>
-                        </a:rPr>
-                        <a:t>≤ 2 Mio. EUR</a:t>
-                      </a:r>
-                    </a:p>
-                  </a:txBody>
-                  <a:tcPr/>
-                </a:tc>
-              </a:tr>
-              <a:tr h="384048">
-                <a:tc>
-                  <a:txBody>
-                    <a:bodyPr/>
-                    <a:lstStyle/>
-                    <a:p>
-                      <a:r>
-                        <a:rPr sz="1050">
-                          <a:solidFill>
-                            <a:srgbClr val="3D5466"/>
-                          </a:solidFill>
-                          <a:latin typeface="Arial"/>
-                        </a:rPr>
-                        <a:t>Kleinunternehmen</a:t>
-                      </a:r>
-                    </a:p>
-                  </a:txBody>
-                  <a:tcPr/>
-                </a:tc>
-                <a:tc>
-                  <a:txBody>
-                    <a:bodyPr/>
-                    <a:lstStyle/>
-                    <a:p>
-                      <a:r>
-                        <a:rPr sz="1050">
-                          <a:solidFill>
-                            <a:srgbClr val="3D5466"/>
-                          </a:solidFill>
-                          <a:latin typeface="Arial"/>
-                        </a:rPr>
-                        <a:t>&lt; 50</a:t>
-                      </a:r>
-                    </a:p>
-                  </a:txBody>
-                  <a:tcPr/>
-                </a:tc>
-                <a:tc>
-                  <a:txBody>
-                    <a:bodyPr/>
-                    <a:lstStyle/>
-                    <a:p>
-                      <a:r>
-                        <a:rPr sz="1050">
-                          <a:solidFill>
-                            <a:srgbClr val="3D5466"/>
-                          </a:solidFill>
-                          <a:latin typeface="Arial"/>
-                        </a:rPr>
-                        <a:t>≤ 10 Mio. EUR</a:t>
-                      </a:r>
-                    </a:p>
-                  </a:txBody>
-                  <a:tcPr/>
-                </a:tc>
-                <a:tc>
-                  <a:txBody>
-                    <a:bodyPr/>
-                    <a:lstStyle/>
-                    <a:p>
-                      <a:r>
-                        <a:rPr sz="1050">
-                          <a:solidFill>
-                            <a:srgbClr val="3D5466"/>
-                          </a:solidFill>
-                          <a:latin typeface="Arial"/>
-                        </a:rPr>
-                        <a:t>≤ 10 Mio. EUR</a:t>
-                      </a:r>
-                    </a:p>
-                  </a:txBody>
-                  <a:tcPr/>
-                </a:tc>
-              </a:tr>
-              <a:tr h="384048">
-                <a:tc>
-                  <a:txBody>
-                    <a:bodyPr/>
-                    <a:lstStyle/>
-                    <a:p>
-                      <a:r>
-                        <a:rPr sz="1050">
-                          <a:solidFill>
-                            <a:srgbClr val="3D5466"/>
-                          </a:solidFill>
-                          <a:latin typeface="Arial"/>
-                        </a:rPr>
-                        <a:t>Mittleres Unternehmen</a:t>
-                      </a:r>
-                    </a:p>
-                  </a:txBody>
-                  <a:tcPr/>
-                </a:tc>
-                <a:tc>
-                  <a:txBody>
-                    <a:bodyPr/>
-                    <a:lstStyle/>
-                    <a:p>
-                      <a:r>
-                        <a:rPr sz="1050">
-                          <a:solidFill>
-                            <a:srgbClr val="3D5466"/>
-                          </a:solidFill>
-                          <a:latin typeface="Arial"/>
-                        </a:rPr>
-                        <a:t>&lt; 250</a:t>
-                      </a:r>
-                    </a:p>
-                  </a:txBody>
-                  <a:tcPr/>
-                </a:tc>
-                <a:tc>
-                  <a:txBody>
-                    <a:bodyPr/>
-                    <a:lstStyle/>
-                    <a:p>
-                      <a:r>
-                        <a:rPr sz="1050">
-                          <a:solidFill>
-                            <a:srgbClr val="3D5466"/>
-                          </a:solidFill>
-                          <a:latin typeface="Arial"/>
-                        </a:rPr>
-                        <a:t>≤ 50 Mio. EUR</a:t>
-                      </a:r>
-                    </a:p>
-                  </a:txBody>
-                  <a:tcPr/>
-                </a:tc>
-                <a:tc>
-                  <a:txBody>
-                    <a:bodyPr/>
-                    <a:lstStyle/>
-                    <a:p>
-                      <a:r>
-                        <a:rPr sz="1050">
-                          <a:solidFill>
-                            <a:srgbClr val="3D5466"/>
-                          </a:solidFill>
-                          <a:latin typeface="Arial"/>
-                        </a:rPr>
-                        <a:t>≤ 43 Mio. EUR</a:t>
-                      </a:r>
-                    </a:p>
-                  </a:txBody>
-                  <a:tcPr/>
-                </a:tc>
-              </a:tr>
-            </a:tbl>
-          </a:graphicData>
-        </a:graphic>
-      </p:graphicFrame>
-      <p:sp>
-        <p:nvSpPr>
-          <p:cNvPr id="8" name="Rectangle 7"/>
+      <p:sp>
+        <p:nvSpPr>
+          <p:cNvPr id="7" name="TextBox 6"/>
+          <p:cNvSpPr txBox="1"/>
+          <p:nvPr/>
+        </p:nvSpPr>
+        <p:spPr>
+          <a:xfrm>
+            <a:off x="813816" y="502920"/>
+            <a:ext cx="10634472" cy="685800"/>
+          </a:xfrm>
+          <a:prstGeom prst="rect">
+            <a:avLst/>
+          </a:prstGeom>
+          <a:noFill/>
+        </p:spPr>
+        <p:txBody>
+          <a:bodyPr wrap="square">
+            <a:spAutoFit/>
+          </a:bodyPr>
+          <a:lstStyle/>
+          <a:p>
+            <a:pPr algn="l"/>
+            <a:r>
+              <a:rPr sz="2400" b="1" i="0">
+                <a:solidFill>
+                  <a:srgbClr val="1F2C56"/>
+                </a:solidFill>
+                <a:latin typeface="Arial"/>
+              </a:rPr>
+              <a:t>Vier zentrale Risikofelder inhabergeführter KMU</a:t>
+            </a:r>
+          </a:p>
+        </p:txBody>
+      </p:sp>
+      <p:sp>
+        <p:nvSpPr>
+          <p:cNvPr id="8" name="TextBox 7"/>
+          <p:cNvSpPr txBox="1"/>
+          <p:nvPr/>
+        </p:nvSpPr>
+        <p:spPr>
+          <a:xfrm>
+            <a:off x="685800" y="1417320"/>
+            <a:ext cx="10817352" cy="4892040"/>
+          </a:xfrm>
+          <a:prstGeom prst="rect">
+            <a:avLst/>
+          </a:prstGeom>
+          <a:noFill/>
+        </p:spPr>
+        <p:txBody>
+          <a:bodyPr wrap="square" anchor="ctr">
+            <a:spAutoFit/>
+          </a:bodyPr>
+          <a:lstStyle/>
+          <a:p>
+            <a:pPr marL="177800" indent="-177800">
+              <a:spcBef>
+                <a:spcPts val="600"/>
+              </a:spcBef>
+              <a:spcAft>
+                <a:spcPts val="200"/>
+              </a:spcAft>
+            </a:pPr>
+            <a:r>
+              <a:rPr sz="1200" i="1">
+                <a:solidFill>
+                  <a:srgbClr val="3D5466"/>
+                </a:solidFill>
+                <a:latin typeface="Arial"/>
+              </a:rPr>
+              <a:t>→  Die typischen KMU-Risiken stehen selten in der Bilanz – sie liegen in der Person und der Struktur.</a:t>
+            </a:r>
+          </a:p>
+          <a:p>
+            <a:pPr marL="190500" indent="-190500">
+              <a:spcBef>
+                <a:spcPts val="400"/>
+              </a:spcBef>
+              <a:spcAft>
+                <a:spcPts val="200"/>
+              </a:spcAft>
+            </a:pPr>
+            <a:r>
+              <a:rPr sz="1300">
+                <a:solidFill>
+                  <a:srgbClr val="3D5466"/>
+                </a:solidFill>
+                <a:latin typeface="Arial"/>
+              </a:rPr>
+              <a:t>▸  Inhaberabhängigkeit / Schlüsselpersonenrisiko: die Person als Single Point of Failure.</a:t>
+            </a:r>
+          </a:p>
+          <a:p>
+            <a:pPr marL="190500" indent="-190500">
+              <a:spcBef>
+                <a:spcPts val="400"/>
+              </a:spcBef>
+              <a:spcAft>
+                <a:spcPts val="200"/>
+              </a:spcAft>
+            </a:pPr>
+            <a:r>
+              <a:rPr sz="1300">
+                <a:solidFill>
+                  <a:srgbClr val="3D5466"/>
+                </a:solidFill>
+                <a:latin typeface="Arial"/>
+              </a:rPr>
+              <a:t>▸  Klumpenrisiko: Abhängigkeit von wenigen Kunden oder Lieferanten.</a:t>
+            </a:r>
+          </a:p>
+          <a:p>
+            <a:pPr marL="190500" indent="-190500">
+              <a:spcBef>
+                <a:spcPts val="400"/>
+              </a:spcBef>
+              <a:spcAft>
+                <a:spcPts val="200"/>
+              </a:spcAft>
+            </a:pPr>
+            <a:r>
+              <a:rPr sz="1300">
+                <a:solidFill>
+                  <a:srgbClr val="3D5466"/>
+                </a:solidFill>
+                <a:latin typeface="Arial"/>
+              </a:rPr>
+              <a:t>▸  Nachfolgerisiko und dünne Eigenkapitaldecke runden das Bild.</a:t>
+            </a:r>
+          </a:p>
+        </p:txBody>
+      </p:sp>
+      <p:sp>
+        <p:nvSpPr>
+          <p:cNvPr id="9" name="Rectangle 8"/>
           <p:cNvSpPr/>
           <p:nvPr/>
         </p:nvSpPr>
@@ -10539,7 +10554,7 @@
       </p:sp>
       <p:sp>
         <p:nvSpPr>
-          <p:cNvPr id="9" name="TextBox 8"/>
+          <p:cNvPr id="10" name="TextBox 9"/>
           <p:cNvSpPr txBox="1"/>
           <p:nvPr/>
         </p:nvSpPr>
@@ -10568,41 +10583,6 @@
                 <a:latin typeface="Consolas"/>
               </a:rPr>
               <a:t>FKB Campus  ·  M06</a:t>
-            </a:r>
-          </a:p>
-        </p:txBody>
-      </p:sp>
-      <p:sp>
-        <p:nvSpPr>
-          <p:cNvPr id="10" name="TextBox 9"/>
-          <p:cNvSpPr txBox="1"/>
-          <p:nvPr/>
-        </p:nvSpPr>
-        <p:spPr>
-          <a:xfrm>
-            <a:off x="7176211" y="6583680"/>
-            <a:ext cx="4326940" cy="256032"/>
-          </a:xfrm>
-          <a:prstGeom prst="rect">
-            <a:avLst/>
-          </a:prstGeom>
-          <a:noFill/>
-        </p:spPr>
-        <p:txBody>
-          <a:bodyPr wrap="none">
-            <a:spAutoFit/>
-          </a:bodyPr>
-          <a:lstStyle/>
-          <a:p>
-            <a:pPr algn="r"/>
-            <a:r>
-              <a:rPr sz="700">
-                <a:solidFill>
-                  <a:srgbClr val="A0B4D2"/>
-                </a:solidFill>
-                <a:latin typeface="Consolas"/>
-              </a:rPr>
-              <a:t>Übersicht</a:t>
             </a:r>
           </a:p>
         </p:txBody>
@@ -10640,7 +10620,7 @@
             <a:avLst/>
           </a:prstGeom>
           <a:solidFill>
-            <a:srgbClr val="EDEDF3"/>
+            <a:srgbClr val="1F2C56"/>
           </a:solidFill>
           <a:ln>
             <a:noFill/>
@@ -10670,57 +10650,14 @@
       </p:sp>
       <p:sp>
         <p:nvSpPr>
-          <p:cNvPr id="3" name="Rectangle 2"/>
-          <p:cNvSpPr/>
-          <p:nvPr/>
-        </p:nvSpPr>
-        <p:spPr>
-          <a:xfrm>
-            <a:off x="0" y="0"/>
-            <a:ext cx="12188952" cy="50292"/>
-          </a:xfrm>
-          <a:prstGeom prst="rect">
-            <a:avLst/>
-          </a:prstGeom>
-          <a:solidFill>
-            <a:srgbClr val="1F2C56"/>
-          </a:solidFill>
-          <a:ln>
-            <a:noFill/>
-          </a:ln>
-        </p:spPr>
-        <p:style>
-          <a:lnRef idx="1">
-            <a:schemeClr val="accent1"/>
-          </a:lnRef>
-          <a:fillRef idx="3">
-            <a:schemeClr val="accent1"/>
-          </a:fillRef>
-          <a:effectRef idx="2">
-            <a:schemeClr val="accent1"/>
-          </a:effectRef>
-          <a:fontRef idx="minor">
-            <a:schemeClr val="lt1"/>
-          </a:fontRef>
-        </p:style>
-        <p:txBody>
-          <a:bodyPr rtlCol="0" anchor="ctr"/>
-          <a:lstStyle/>
-          <a:p>
-            <a:pPr algn="ctr"/>
-          </a:p>
-        </p:txBody>
-      </p:sp>
-      <p:sp>
-        <p:nvSpPr>
-          <p:cNvPr id="4" name="TextBox 3"/>
+          <p:cNvPr id="3" name="TextBox 2"/>
           <p:cNvSpPr txBox="1"/>
           <p:nvPr/>
         </p:nvSpPr>
         <p:spPr>
           <a:xfrm>
-            <a:off x="685800" y="109728"/>
-            <a:ext cx="10817352" cy="228600"/>
+            <a:off x="685800" y="2377440"/>
+            <a:ext cx="10817352" cy="365760"/>
           </a:xfrm>
           <a:prstGeom prst="rect">
             <a:avLst/>
@@ -10735,70 +10672,27 @@
           <a:p>
             <a:pPr algn="l"/>
             <a:r>
-              <a:rPr sz="750">
-                <a:solidFill>
-                  <a:srgbClr val="78808C"/>
+              <a:rPr sz="1200">
+                <a:solidFill>
+                  <a:srgbClr val="D9C089"/>
                 </a:solidFill>
                 <a:latin typeface="Consolas"/>
               </a:rPr>
-              <a:t>M06  ·  INHALT</a:t>
-            </a:r>
-          </a:p>
-        </p:txBody>
-      </p:sp>
-      <p:sp>
-        <p:nvSpPr>
-          <p:cNvPr id="5" name="Rectangle 4"/>
+              <a:t>WERKZEUG</a:t>
+            </a:r>
+          </a:p>
+        </p:txBody>
+      </p:sp>
+      <p:sp>
+        <p:nvSpPr>
+          <p:cNvPr id="4" name="Rectangle 3"/>
           <p:cNvSpPr/>
           <p:nvPr/>
         </p:nvSpPr>
         <p:spPr>
           <a:xfrm>
-            <a:off x="0" y="1234440"/>
-            <a:ext cx="12188952" cy="12700"/>
-          </a:xfrm>
-          <a:prstGeom prst="rect">
-            <a:avLst/>
-          </a:prstGeom>
-          <a:solidFill>
-            <a:srgbClr val="D8DFE4"/>
-          </a:solidFill>
-          <a:ln>
-            <a:noFill/>
-          </a:ln>
-        </p:spPr>
-        <p:style>
-          <a:lnRef idx="1">
-            <a:schemeClr val="accent1"/>
-          </a:lnRef>
-          <a:fillRef idx="3">
-            <a:schemeClr val="accent1"/>
-          </a:fillRef>
-          <a:effectRef idx="2">
-            <a:schemeClr val="accent1"/>
-          </a:effectRef>
-          <a:fontRef idx="minor">
-            <a:schemeClr val="lt1"/>
-          </a:fontRef>
-        </p:style>
-        <p:txBody>
-          <a:bodyPr rtlCol="0" anchor="ctr"/>
-          <a:lstStyle/>
-          <a:p>
-            <a:pPr algn="ctr"/>
-          </a:p>
-        </p:txBody>
-      </p:sp>
-      <p:sp>
-        <p:nvSpPr>
-          <p:cNvPr id="6" name="Rectangle 5"/>
-          <p:cNvSpPr/>
-          <p:nvPr/>
-        </p:nvSpPr>
-        <p:spPr>
-          <a:xfrm>
-            <a:off x="685800" y="502920"/>
-            <a:ext cx="36576" cy="658368"/>
+            <a:off x="685800" y="2788920"/>
+            <a:ext cx="548640" cy="38100"/>
           </a:xfrm>
           <a:prstGeom prst="rect">
             <a:avLst/>
@@ -10834,14 +10728,14 @@
       </p:sp>
       <p:sp>
         <p:nvSpPr>
-          <p:cNvPr id="7" name="TextBox 6"/>
+          <p:cNvPr id="5" name="TextBox 4"/>
           <p:cNvSpPr txBox="1"/>
           <p:nvPr/>
         </p:nvSpPr>
         <p:spPr>
           <a:xfrm>
-            <a:off x="813816" y="502920"/>
-            <a:ext cx="10634472" cy="685800"/>
+            <a:off x="685800" y="3017520"/>
+            <a:ext cx="10817352" cy="1463040"/>
           </a:xfrm>
           <a:prstGeom prst="rect">
             <a:avLst/>
@@ -10856,27 +10750,27 @@
           <a:p>
             <a:pPr algn="l"/>
             <a:r>
-              <a:rPr sz="2400" b="1" i="0">
-                <a:solidFill>
-                  <a:srgbClr val="1F2C56"/>
+              <a:rPr sz="4000" b="1" i="0">
+                <a:solidFill>
+                  <a:srgbClr val="FFFFFF"/>
                 </a:solidFill>
                 <a:latin typeface="Arial"/>
               </a:rPr>
-              <a:t>Theorie-Input 2: Finanzierungsmuster und typische Risikofelder</a:t>
-            </a:r>
-          </a:p>
-        </p:txBody>
-      </p:sp>
-      <p:sp>
-        <p:nvSpPr>
-          <p:cNvPr id="8" name="TextBox 7"/>
+              <a:t>Einstieg in die Branchenanalyse</a:t>
+            </a:r>
+          </a:p>
+        </p:txBody>
+      </p:sp>
+      <p:sp>
+        <p:nvSpPr>
+          <p:cNvPr id="6" name="TextBox 5"/>
           <p:cNvSpPr txBox="1"/>
           <p:nvPr/>
         </p:nvSpPr>
         <p:spPr>
           <a:xfrm>
-            <a:off x="685800" y="1417320"/>
-            <a:ext cx="10817352" cy="4892040"/>
+            <a:off x="685800" y="4480560"/>
+            <a:ext cx="8653881" cy="1280160"/>
           </a:xfrm>
           <a:prstGeom prst="rect">
             <a:avLst/>
@@ -10889,288 +10783,29 @@
           </a:bodyPr>
           <a:lstStyle/>
           <a:p>
-            <a:pPr>
-              <a:spcBef>
-                <a:spcPts val="1000"/>
-              </a:spcBef>
-              <a:spcAft>
-                <a:spcPts val="200"/>
-              </a:spcAft>
-            </a:pPr>
-            <a:r>
-              <a:rPr sz="800" b="1">
-                <a:solidFill>
-                  <a:srgbClr val="78808C"/>
-                </a:solidFill>
-                <a:latin typeface="Consolas"/>
-              </a:rPr>
-              <a:t>FINANZIERUNGSSTRUKTUR: KMU VS. GROSSUNTERNEHMEN</a:t>
-            </a:r>
-          </a:p>
-          <a:p>
-            <a:pPr marL="190500" indent="-190500">
-              <a:spcBef>
-                <a:spcPts val="400"/>
-              </a:spcBef>
-              <a:spcAft>
-                <a:spcPts val="200"/>
-              </a:spcAft>
-            </a:pPr>
-            <a:r>
-              <a:rPr sz="1300">
-                <a:solidFill>
-                  <a:srgbClr val="3D5466"/>
+            <a:pPr algn="l"/>
+            <a:r>
+              <a:rPr sz="1600" b="0" i="0">
+                <a:solidFill>
+                  <a:srgbClr val="C8D2E6"/>
                 </a:solidFill>
                 <a:latin typeface="Arial"/>
               </a:rPr>
-              <a:t>▸  Die Finanzierungsstruktur von KMU unterscheidet sich strukturell von der großer Unternehmen. Diese Unterschiede zu kennen, ist die Grundlage jeder fundierten Kreditanalyse.</a:t>
-            </a:r>
-          </a:p>
-          <a:p>
-            <a:pPr marL="190500" indent="-190500">
-              <a:spcBef>
-                <a:spcPts val="400"/>
-              </a:spcBef>
-              <a:spcAft>
-                <a:spcPts val="200"/>
-              </a:spcAft>
-            </a:pPr>
-            <a:r>
-              <a:rPr sz="1300">
-                <a:solidFill>
-                  <a:srgbClr val="3D5466"/>
-                </a:solidFill>
-                <a:latin typeface="Arial"/>
-              </a:rPr>
-              <a:t>▸  Eigenkapitalquoten:</a:t>
-            </a:r>
-          </a:p>
-          <a:p>
-            <a:pPr marL="190500" indent="-190500">
-              <a:spcBef>
-                <a:spcPts val="400"/>
-              </a:spcBef>
-              <a:spcAft>
-                <a:spcPts val="200"/>
-              </a:spcAft>
-            </a:pPr>
-            <a:r>
-              <a:rPr sz="1300">
-                <a:solidFill>
-                  <a:srgbClr val="3D5466"/>
-                </a:solidFill>
-                <a:latin typeface="Arial"/>
-              </a:rPr>
-              <a:t>▸  Steuerliche Optimierung: KMU-Inhaber entnehmen Gewinne für den privaten Lebensunterhalt, statt sie im Betrieb zu thesaurieren</a:t>
-            </a:r>
-          </a:p>
-          <a:p>
-            <a:pPr marL="190500" indent="-190500">
-              <a:spcBef>
-                <a:spcPts val="400"/>
-              </a:spcBef>
-              <a:spcAft>
-                <a:spcPts val="200"/>
-              </a:spcAft>
-            </a:pPr>
-            <a:r>
-              <a:rPr sz="1300">
-                <a:solidFill>
-                  <a:srgbClr val="3D5466"/>
-                </a:solidFill>
-                <a:latin typeface="Arial"/>
-              </a:rPr>
-              <a:t>▸  Verflechtung Privat/Betrieb: Privatliegenschaften des Inhabers erscheinen nicht in der Bilanz, sind aber reale Sicherheiten</a:t>
-            </a:r>
-          </a:p>
-          <a:p>
-            <a:pPr marL="190500" indent="-190500">
-              <a:spcBef>
-                <a:spcPts val="400"/>
-              </a:spcBef>
-              <a:spcAft>
-                <a:spcPts val="200"/>
-              </a:spcAft>
-            </a:pPr>
-            <a:r>
-              <a:rPr sz="1300">
-                <a:solidFill>
-                  <a:srgbClr val="3D5466"/>
-                </a:solidFill>
-                <a:latin typeface="Arial"/>
-              </a:rPr>
-              <a:t>▸  Vorsichtige Bilanzpolitik: Viele KMU nutzen steuerliche Abschreibungsmöglichkeiten maximal – die Bilanz ist dadurch "schlechter" als die wirtschaftliche Realität</a:t>
-            </a:r>
-          </a:p>
-          <a:p>
-            <a:pPr marL="190500" indent="-190500">
-              <a:spcBef>
-                <a:spcPts val="400"/>
-              </a:spcBef>
-              <a:spcAft>
-                <a:spcPts val="200"/>
-              </a:spcAft>
-            </a:pPr>
-            <a:r>
-              <a:rPr sz="1300">
-                <a:solidFill>
-                  <a:srgbClr val="3D5466"/>
-                </a:solidFill>
-                <a:latin typeface="Arial"/>
-              </a:rPr>
-              <a:t>▸  Finanzierungsquellen:</a:t>
-            </a:r>
-          </a:p>
-          <a:p>
-            <a:pPr marL="190500" indent="-190500">
-              <a:spcBef>
-                <a:spcPts val="400"/>
-              </a:spcBef>
-              <a:spcAft>
-                <a:spcPts val="200"/>
-              </a:spcAft>
-            </a:pPr>
-            <a:r>
-              <a:rPr sz="1300">
-                <a:solidFill>
-                  <a:srgbClr val="3D5466"/>
-                </a:solidFill>
-                <a:latin typeface="Arial"/>
-              </a:rPr>
-              <a:t>▸  KMU finanzieren sich typischerweise durch drei Hauptquellen:</a:t>
-            </a:r>
-          </a:p>
-          <a:p>
-            <a:pPr marL="190500" indent="-190500">
-              <a:spcBef>
-                <a:spcPts val="400"/>
-              </a:spcBef>
-              <a:spcAft>
-                <a:spcPts val="200"/>
-              </a:spcAft>
-            </a:pPr>
-            <a:r>
-              <a:rPr sz="1300">
-                <a:solidFill>
-                  <a:srgbClr val="3D5466"/>
-                </a:solidFill>
-                <a:latin typeface="Arial"/>
-              </a:rPr>
-              <a:t>▸  Innenfinanzierung (Thesaurierung): Gewinne verbleiben im Unternehmen – bei inhabergeführten Betrieben stark limitiert durch private Entnahmen</a:t>
-            </a:r>
-          </a:p>
-          <a:p>
-            <a:pPr marL="190500" indent="-190500">
-              <a:spcBef>
-                <a:spcPts val="400"/>
-              </a:spcBef>
-              <a:spcAft>
-                <a:spcPts val="200"/>
-              </a:spcAft>
-            </a:pPr>
-            <a:r>
-              <a:rPr sz="1300">
-                <a:solidFill>
-                  <a:srgbClr val="3D5466"/>
-                </a:solidFill>
-                <a:latin typeface="Arial"/>
-              </a:rPr>
-              <a:t>▸  Bankkredite (Außenfinanzierung): Investitionskredite, Kontokorrentlinien, Avale – dominante Finanzierungsform</a:t>
-            </a:r>
-          </a:p>
-          <a:p>
-            <a:pPr marL="190500" indent="-190500">
-              <a:spcBef>
-                <a:spcPts val="400"/>
-              </a:spcBef>
-              <a:spcAft>
-                <a:spcPts val="200"/>
-              </a:spcAft>
-            </a:pPr>
-            <a:r>
-              <a:rPr sz="1300">
-                <a:solidFill>
-                  <a:srgbClr val="3D5466"/>
-                </a:solidFill>
-                <a:latin typeface="Arial"/>
-              </a:rPr>
-              <a:t>▸  Öffentliche Förderprogramme: KfW-Unternehmenskredit, ERP-Kapital für Gründung, Landesförderprogramme – häufig günstiger als Hausbankkonditionen, oft nicht ausgeschöpft</a:t>
-            </a:r>
-          </a:p>
-          <a:p>
-            <a:pPr marL="190500" indent="-190500">
-              <a:spcBef>
-                <a:spcPts val="400"/>
-              </a:spcBef>
-              <a:spcAft>
-                <a:spcPts val="200"/>
-              </a:spcAft>
-            </a:pPr>
-            <a:r>
-              <a:rPr sz="1300">
-                <a:solidFill>
-                  <a:srgbClr val="3D5466"/>
-                </a:solidFill>
-                <a:latin typeface="Arial"/>
-              </a:rPr>
-              <a:t>▸  Die drei meistgenutzten Förderprogramme in der süddeutschen VR-Praxis:</a:t>
-            </a:r>
-          </a:p>
-        </p:txBody>
-      </p:sp>
-      <p:sp>
-        <p:nvSpPr>
-          <p:cNvPr id="9" name="Rectangle 8"/>
-          <p:cNvSpPr/>
-          <p:nvPr/>
-        </p:nvSpPr>
-        <p:spPr>
-          <a:xfrm>
-            <a:off x="0" y="6510528"/>
-            <a:ext cx="12188952" cy="347472"/>
-          </a:xfrm>
-          <a:prstGeom prst="rect">
-            <a:avLst/>
-          </a:prstGeom>
-          <a:solidFill>
-            <a:srgbClr val="0A1937"/>
-          </a:solidFill>
-          <a:ln>
-            <a:noFill/>
-          </a:ln>
-        </p:spPr>
-        <p:style>
-          <a:lnRef idx="1">
-            <a:schemeClr val="accent1"/>
-          </a:lnRef>
-          <a:fillRef idx="3">
-            <a:schemeClr val="accent1"/>
-          </a:fillRef>
-          <a:effectRef idx="2">
-            <a:schemeClr val="accent1"/>
-          </a:effectRef>
-          <a:fontRef idx="minor">
-            <a:schemeClr val="lt1"/>
-          </a:fontRef>
-        </p:style>
-        <p:txBody>
-          <a:bodyPr rtlCol="0" anchor="ctr"/>
-          <a:lstStyle/>
-          <a:p>
-            <a:pPr algn="ctr"/>
-          </a:p>
-        </p:txBody>
-      </p:sp>
-      <p:sp>
-        <p:nvSpPr>
-          <p:cNvPr id="10" name="TextBox 9"/>
+              <a:t>Zahlen in den Branchenkontext stellen – mit dem 5-Fragen-Schema.</a:t>
+            </a:r>
+          </a:p>
+        </p:txBody>
+      </p:sp>
+      <p:sp>
+        <p:nvSpPr>
+          <p:cNvPr id="7" name="TextBox 6"/>
           <p:cNvSpPr txBox="1"/>
           <p:nvPr/>
         </p:nvSpPr>
         <p:spPr>
           <a:xfrm>
-            <a:off x="685800" y="6583680"/>
-            <a:ext cx="6490411" cy="256032"/>
+            <a:off x="685800" y="6355080"/>
+            <a:ext cx="10817352" cy="274320"/>
           </a:xfrm>
           <a:prstGeom prst="rect">
             <a:avLst/>
@@ -11187,7 +10822,7 @@
             <a:r>
               <a:rPr sz="700">
                 <a:solidFill>
-                  <a:srgbClr val="A0B4D2"/>
+                  <a:srgbClr val="8CA0C3"/>
                 </a:solidFill>
                 <a:latin typeface="Consolas"/>
               </a:rPr>

</xml_diff>